<commit_message>
Add "Sandboxed paths" slide; make PPTX the deck source of truth
Add a slide after "SQLite everywhere" enumerating the sandbox URI schemes
(skill:// / storage:// / tmp://) with descriptions, styled to match the deck.
Update OUTLINE.md to reference slides-pptx.pptx as the source of truth (dropping
the abandoned Quarto plan) with an accurate 30-slide map, and add a terse
AGENTS.md describing how to edit the deck via python-pptx (venv at repo .venv).
Ignore /.venv/.

Co-Authored-By: Claude Opus 4.8 <noreply@anthropic.com>
</commit_message>
<xml_diff>
--- a/docs/croai2026/slides-pptx.pptx
+++ b/docs/croai2026/slides-pptx.pptx
@@ -5,7 +5,7 @@
     <p:sldMasterId id="2147483648" r:id="rId1"/>
   </p:sldMasterIdLst>
   <p:notesMasterIdLst>
-    <p:notesMasterId r:id="rId31"/>
+    <p:notesMasterId r:id="rId32"/>
   </p:notesMasterIdLst>
   <p:sldIdLst>
     <p:sldId id="256" r:id="rId2"/>
@@ -25,18 +25,19 @@
     <p:sldId id="268" r:id="rId16"/>
     <p:sldId id="269" r:id="rId17"/>
     <p:sldId id="270" r:id="rId18"/>
-    <p:sldId id="271" r:id="rId19"/>
-    <p:sldId id="272" r:id="rId20"/>
-    <p:sldId id="273" r:id="rId21"/>
-    <p:sldId id="274" r:id="rId22"/>
-    <p:sldId id="283" r:id="rId23"/>
-    <p:sldId id="275" r:id="rId24"/>
-    <p:sldId id="276" r:id="rId25"/>
-    <p:sldId id="277" r:id="rId26"/>
-    <p:sldId id="278" r:id="rId27"/>
-    <p:sldId id="279" r:id="rId28"/>
-    <p:sldId id="280" r:id="rId29"/>
-    <p:sldId id="281" r:id="rId30"/>
+    <p:sldId id="287" r:id="rId19"/>
+    <p:sldId id="271" r:id="rId20"/>
+    <p:sldId id="272" r:id="rId21"/>
+    <p:sldId id="273" r:id="rId22"/>
+    <p:sldId id="274" r:id="rId23"/>
+    <p:sldId id="283" r:id="rId24"/>
+    <p:sldId id="275" r:id="rId25"/>
+    <p:sldId id="276" r:id="rId26"/>
+    <p:sldId id="277" r:id="rId27"/>
+    <p:sldId id="278" r:id="rId28"/>
+    <p:sldId id="279" r:id="rId29"/>
+    <p:sldId id="280" r:id="rId30"/>
+    <p:sldId id="281" r:id="rId31"/>
   </p:sldIdLst>
   <p:sldSz cx="9144000" cy="5143500" type="screen16x9"/>
   <p:notesSz cx="6858000" cy="9144000"/>
@@ -664,7 +665,7 @@
           <a:p>
             <a:fld id="{18BDFEC3-8487-43E8-A154-7C12CBC1FFF2}" type="slidenum">
               <a:rPr lang="en-US"/>
-              <a:t>20</a:t>
+              <a:t>21</a:t>
             </a:fld>
             <a:endParaRPr lang="en-US"/>
           </a:p>
@@ -748,7 +749,7 @@
           <a:p>
             <a:fld id="{18BDFEC3-8487-43E8-A154-7C12CBC1FFF2}" type="slidenum">
               <a:rPr lang="en-US"/>
-              <a:t>21</a:t>
+              <a:t>22</a:t>
             </a:fld>
             <a:endParaRPr lang="en-US"/>
           </a:p>
@@ -902,7 +903,7 @@
           <a:p>
             <a:fld id="{18BDFEC3-8487-43E8-A154-7C12CBC1FFF2}" type="slidenum">
               <a:rPr lang="en-US"/>
-              <a:t>24</a:t>
+              <a:t>25</a:t>
             </a:fld>
             <a:endParaRPr lang="en-US"/>
           </a:p>
@@ -986,7 +987,7 @@
           <a:p>
             <a:fld id="{18BDFEC3-8487-43E8-A154-7C12CBC1FFF2}" type="slidenum">
               <a:rPr lang="en-US"/>
-              <a:t>26</a:t>
+              <a:t>27</a:t>
             </a:fld>
             <a:endParaRPr lang="en-US"/>
           </a:p>
@@ -1070,7 +1071,7 @@
           <a:p>
             <a:fld id="{18BDFEC3-8487-43E8-A154-7C12CBC1FFF2}" type="slidenum">
               <a:rPr lang="en-US"/>
-              <a:t>27</a:t>
+              <a:t>28</a:t>
             </a:fld>
             <a:endParaRPr lang="en-US"/>
           </a:p>
@@ -1742,7 +1743,7 @@
           <a:p>
             <a:fld id="{18BDFEC3-8487-43E8-A154-7C12CBC1FFF2}" type="slidenum">
               <a:rPr lang="en-US"/>
-              <a:t>18</a:t>
+              <a:t>19</a:t>
             </a:fld>
             <a:endParaRPr lang="en-US"/>
           </a:p>
@@ -6913,7 +6914,7 @@
         <p:spPr/>
         <p:txBody>
           <a:bodyPr>
-            <a:normAutofit fontScale="70000" lnSpcReduction="20000"/>
+            <a:normAutofit fontScale="85000" lnSpcReduction="10000"/>
           </a:bodyPr>
           <a:lstStyle/>
           <a:p>
@@ -6921,7 +6922,8 @@
               <a:buNone/>
             </a:pPr>
             <a:r>
-              <a:t>Three tiers, all WAL:</a:t>
+              <a:rPr dirty="0"/>
+              <a:t>Three tiers:</a:t>
             </a:r>
           </a:p>
           <a:p>
@@ -6929,66 +6931,138 @@
               <a:buNone/>
             </a:pPr>
             <a:r>
-              <a:rPr>
+              <a:rPr sz="2100" dirty="0">
                 <a:latin typeface="Courier"/>
               </a:rPr>
-              <a:t>data/harlequin.db          system: users, tokens          (kept open)
-data/shared.db             org: shared memories, docs     (kept open)
-data/users/&lt;id&gt;/user.db    memories, conversations, cron  (opened per request)</a:t>
-            </a:r>
+              <a:t>data/</a:t>
+            </a:r>
+            <a:r>
+              <a:rPr sz="2100" dirty="0" err="1">
+                <a:latin typeface="Courier"/>
+              </a:rPr>
+              <a:t>harlequin.db</a:t>
+            </a:r>
+            <a:r>
+              <a:rPr sz="2100" dirty="0">
+                <a:latin typeface="Courier"/>
+              </a:rPr>
+              <a:t>        system: users, tokens          data/</a:t>
+            </a:r>
+            <a:r>
+              <a:rPr sz="2100" dirty="0" err="1">
+                <a:latin typeface="Courier"/>
+              </a:rPr>
+              <a:t>shared.db</a:t>
+            </a:r>
+            <a:r>
+              <a:rPr sz="2100" dirty="0">
+                <a:latin typeface="Courier"/>
+              </a:rPr>
+              <a:t>           org: shared memories, docs     </a:t>
+            </a:r>
+            <a:endParaRPr lang="hr-HR" sz="2100" dirty="0">
+              <a:latin typeface="Courier"/>
+            </a:endParaRPr>
+          </a:p>
+          <a:p>
+            <a:pPr lvl="0" indent="0">
+              <a:buNone/>
+            </a:pPr>
+            <a:r>
+              <a:rPr sz="2100" dirty="0">
+                <a:latin typeface="Courier"/>
+              </a:rPr>
+              <a:t>data/users/&lt;id&gt;/</a:t>
+            </a:r>
+            <a:r>
+              <a:rPr sz="2100" dirty="0" err="1">
+                <a:latin typeface="Courier"/>
+              </a:rPr>
+              <a:t>user.db</a:t>
+            </a:r>
+            <a:r>
+              <a:rPr sz="2100" dirty="0">
+                <a:latin typeface="Courier"/>
+              </a:rPr>
+              <a:t>  memories, conversations, </a:t>
+            </a:r>
+            <a:r>
+              <a:rPr sz="2100" dirty="0" err="1">
+                <a:latin typeface="Courier"/>
+              </a:rPr>
+              <a:t>cron</a:t>
+            </a:r>
+            <a:endParaRPr lang="en-GB" sz="2100" dirty="0">
+              <a:latin typeface="Courier"/>
+            </a:endParaRPr>
           </a:p>
           <a:p>
             <a:pPr lvl="0"/>
             <a:r>
+              <a:rPr lang="en-GB" dirty="0"/>
               <a:t>Per-user DBs opened per request, closed after — thousands of users, no connection pools</a:t>
             </a:r>
           </a:p>
           <a:p>
             <a:pPr lvl="0"/>
             <a:r>
+              <a:rPr dirty="0"/>
               <a:t>No cross-file foreign keys: composite ids (</a:t>
             </a:r>
             <a:r>
-              <a:rPr>
+              <a:rPr dirty="0">
                 <a:latin typeface="Courier"/>
               </a:rPr>
               <a:t>u.4</a:t>
             </a:r>
             <a:r>
+              <a:rPr dirty="0"/>
               <a:t> / </a:t>
             </a:r>
             <a:r>
-              <a:rPr>
+              <a:rPr dirty="0">
                 <a:latin typeface="Courier"/>
               </a:rPr>
               <a:t>s.7</a:t>
             </a:r>
             <a:r>
+              <a:rPr dirty="0"/>
               <a:t>) fuse the tiers in code</a:t>
             </a:r>
           </a:p>
           <a:p>
             <a:pPr lvl="0"/>
             <a:r>
+              <a:rPr dirty="0"/>
               <a:t>FTS5 + </a:t>
             </a:r>
             <a:r>
-              <a:rPr>
+              <a:rPr dirty="0" err="1">
                 <a:latin typeface="Courier"/>
               </a:rPr>
               <a:t>sqlite-vec</a:t>
             </a:r>
             <a:r>
-              <a:t> in the same file: full-text and vector search </a:t>
-            </a:r>
-            <a:r>
-              <a:rPr b="1"/>
+              <a:rPr dirty="0"/>
+              <a:t> in the same file</a:t>
+            </a:r>
+            <a:endParaRPr lang="hr-HR" dirty="0"/>
+          </a:p>
+          <a:p>
+            <a:pPr lvl="1"/>
+            <a:r>
+              <a:rPr dirty="0"/>
+              <a:t>full-text and vector search </a:t>
+            </a:r>
+            <a:r>
+              <a:rPr b="1" dirty="0"/>
               <a:t>next to the data</a:t>
             </a:r>
           </a:p>
           <a:p>
             <a:pPr lvl="0"/>
             <a:r>
+              <a:rPr dirty="0"/>
               <a:t>Backup = copy a directory; per-user isolation by construction</a:t>
             </a:r>
           </a:p>
@@ -7034,86 +7108,141 @@
           <a:bodyPr/>
           <a:lstStyle/>
           <a:p>
-            <a:pPr marL="0" lvl="0" indent="0">
+            <a:r>
+              <a:t>Sandboxed paths</a:t>
+            </a:r>
+          </a:p>
+        </p:txBody>
+      </p:sp>
+      <p:sp>
+        <p:nvSpPr>
+          <p:cNvPr id="3" name="Content Placeholder 2"/>
+          <p:cNvSpPr>
+            <a:spLocks noGrp="1"/>
+          </p:cNvSpPr>
+          <p:nvPr>
+            <p:ph idx="1"/>
+          </p:nvPr>
+        </p:nvSpPr>
+        <p:spPr/>
+        <p:txBody>
+          <a:bodyPr wrap="square">
+            <a:normAutofit fontScale="85000" lnSpcReduction="20000"/>
+          </a:bodyPr>
+          <a:lstStyle/>
+          <a:p>
+            <a:pPr>
               <a:buNone/>
             </a:pPr>
             <a:r>
-              <a:t>Embeddings to speed things up</a:t>
-            </a:r>
-          </a:p>
-        </p:txBody>
-      </p:sp>
-      <p:sp>
-        <p:nvSpPr>
-          <p:cNvPr id="3" name="Content Placeholder 2"/>
-          <p:cNvSpPr>
-            <a:spLocks noGrp="1"/>
-          </p:cNvSpPr>
-          <p:nvPr>
-            <p:ph idx="1"/>
-          </p:nvPr>
-        </p:nvSpPr>
-        <p:spPr/>
-        <p:txBody>
-          <a:bodyPr>
-            <a:normAutofit fontScale="92500" lnSpcReduction="10000"/>
-          </a:bodyPr>
-          <a:lstStyle/>
-          <a:p>
-            <a:pPr lvl="0"/>
-            <a:r>
-              <a:t>311M multilingual embedder (granite) on its own llama.cpp — cheap, always available</a:t>
-            </a:r>
-          </a:p>
-          <a:p>
-            <a:pPr lvl="0"/>
-            <a:r>
-              <a:t>Hybrid retrieval: FTS5 + vector legs fused with </a:t>
-            </a:r>
-            <a:r>
-              <a:rPr b="1"/>
-              <a:t>Reciprocal Rank Fusion</a:t>
-            </a:r>
-          </a:p>
-          <a:p>
-            <a:pPr lvl="0"/>
-            <a:r>
-              <a:t>Embeddings as a </a:t>
-            </a:r>
-            <a:r>
-              <a:rPr b="1"/>
-              <a:t>pre-filter for LLM judges</a:t>
-            </a:r>
-            <a:r>
-              <a:t>: only top candidate pairs reach the 26B model</a:t>
-            </a:r>
-          </a:p>
-          <a:p>
-            <a:pPr lvl="0"/>
-            <a:r>
-              <a:t>Slot keys (</a:t>
-            </a:r>
-            <a:r>
-              <a:rPr>
+              <a:rPr lang="hr-HR" dirty="0"/>
+              <a:t>JS</a:t>
+            </a:r>
+            <a:r>
+              <a:rPr dirty="0"/>
+              <a:t> sandbox and tools resolve </a:t>
+            </a:r>
+            <a:r>
+              <a:rPr lang="hr-HR" dirty="0" err="1"/>
+              <a:t>special</a:t>
+            </a:r>
+            <a:r>
+              <a:rPr lang="hr-HR" dirty="0"/>
+              <a:t> file </a:t>
+            </a:r>
+            <a:r>
+              <a:rPr lang="hr-HR" dirty="0" err="1"/>
+              <a:t>paths</a:t>
+            </a:r>
+            <a:r>
+              <a:rPr lang="hr-HR" dirty="0"/>
+              <a:t>:</a:t>
+            </a:r>
+            <a:endParaRPr dirty="0"/>
+          </a:p>
+          <a:p>
+            <a:r>
+              <a:rPr b="1" dirty="0">
                 <a:latin typeface="Courier"/>
               </a:rPr>
-              <a:t>user.preferred_currency</a:t>
-            </a:r>
-            <a:r>
-              <a:t>) get their own embedding leg</a:t>
-            </a:r>
-          </a:p>
-          <a:p>
-            <a:pPr marL="1270000" lvl="0" indent="0">
+              <a:t>skill://&lt;skill&gt;/&lt;path&gt;</a:t>
+            </a:r>
+            <a:r>
+              <a:rPr dirty="0"/>
+              <a:t>  — read-only files from a skill bundle; resolution honors overrides (hat → user → org → deployed); backs load()/include(), </a:t>
+            </a:r>
+            <a:r>
+              <a:rPr dirty="0" err="1"/>
+              <a:t>run_js</a:t>
+            </a:r>
+            <a:r>
+              <a:rPr dirty="0"/>
+              <a:t>, and </a:t>
+            </a:r>
+            <a:r>
+              <a:rPr dirty="0" err="1"/>
+              <a:t>cron</a:t>
+            </a:r>
+            <a:r>
+              <a:rPr dirty="0"/>
+              <a:t> </a:t>
+            </a:r>
+            <a:r>
+              <a:rPr dirty="0" err="1"/>
+              <a:t>js</a:t>
+            </a:r>
+            <a:r>
+              <a:rPr dirty="0"/>
+              <a:t> targets</a:t>
+            </a:r>
+          </a:p>
+          <a:p>
+            <a:r>
+              <a:rPr b="1" dirty="0">
+                <a:latin typeface="Courier"/>
+              </a:rPr>
+              <a:t>storage://&lt;path&gt;</a:t>
+            </a:r>
+            <a:r>
+              <a:rPr dirty="0"/>
+              <a:t>  — per-user persistent store (.storage): read / write / list / remove / exists; survives runs — generated parsers, saved recipes, web-watch baselines</a:t>
+            </a:r>
+          </a:p>
+          <a:p>
+            <a:r>
+              <a:rPr b="1" dirty="0">
+                <a:latin typeface="Courier"/>
+              </a:rPr>
+              <a:t>tmp://&lt;path&gt;</a:t>
+            </a:r>
+            <a:r>
+              <a:rPr dirty="0"/>
+              <a:t>  — per-user transient scratch (.</a:t>
+            </a:r>
+            <a:r>
+              <a:rPr dirty="0" err="1"/>
+              <a:t>tmp</a:t>
+            </a:r>
+            <a:r>
+              <a:rPr dirty="0"/>
+              <a:t>): same API, ephemeral — e.g. </a:t>
+            </a:r>
+            <a:r>
+              <a:rPr dirty="0" err="1"/>
+              <a:t>WebFetchDOM</a:t>
+            </a:r>
+            <a:r>
+              <a:rPr dirty="0"/>
+              <a:t> stashes a fetched page as a tmp:// handle</a:t>
+            </a:r>
+          </a:p>
+          <a:p>
+            <a:pPr>
               <a:buNone/>
             </a:pPr>
             <a:r>
-              <a:rPr sz="2000" b="1"/>
-              <a:t>Theme:</a:t>
-            </a:r>
-            <a:r>
-              <a:rPr sz="2000"/>
-              <a:t> the 311M model runs constantly so the 26B model runs rarely.</a:t>
+              <a:rPr i="1" dirty="0"/>
+              <a:t>One resolver; unknown scheme → error. No host filesystem or network outside these roots.</a:t>
             </a:r>
           </a:p>
         </p:txBody>
@@ -7162,7 +7291,7 @@
               <a:buNone/>
             </a:pPr>
             <a:r>
-              <a:t>Measured: slot-key embedding leg</a:t>
+              <a:t>Embeddings to speed things up</a:t>
             </a:r>
           </a:p>
         </p:txBody>
@@ -7179,14 +7308,65 @@
         </p:nvSpPr>
         <p:spPr/>
         <p:txBody>
-          <a:bodyPr/>
+          <a:bodyPr>
+            <a:normAutofit fontScale="92500" lnSpcReduction="10000"/>
+          </a:bodyPr>
           <a:lstStyle/>
           <a:p>
-            <a:pPr marL="0" lvl="0" indent="0">
+            <a:pPr lvl="0"/>
+            <a:r>
+              <a:t>311M multilingual embedder (granite) on its own llama.cpp — cheap, always available</a:t>
+            </a:r>
+          </a:p>
+          <a:p>
+            <a:pPr lvl="0"/>
+            <a:r>
+              <a:t>Hybrid retrieval: FTS5 + vector legs fused with </a:t>
+            </a:r>
+            <a:r>
+              <a:rPr b="1"/>
+              <a:t>Reciprocal Rank Fusion</a:t>
+            </a:r>
+          </a:p>
+          <a:p>
+            <a:pPr lvl="0"/>
+            <a:r>
+              <a:t>Embeddings as a </a:t>
+            </a:r>
+            <a:r>
+              <a:rPr b="1"/>
+              <a:t>pre-filter for LLM judges</a:t>
+            </a:r>
+            <a:r>
+              <a:t>: only top candidate pairs reach the 26B model</a:t>
+            </a:r>
+          </a:p>
+          <a:p>
+            <a:pPr lvl="0"/>
+            <a:r>
+              <a:t>Slot keys (</a:t>
+            </a:r>
+            <a:r>
+              <a:rPr>
+                <a:latin typeface="Courier"/>
+              </a:rPr>
+              <a:t>user.preferred_currency</a:t>
+            </a:r>
+            <a:r>
+              <a:t>) get their own embedding leg</a:t>
+            </a:r>
+          </a:p>
+          <a:p>
+            <a:pPr marL="1270000" lvl="0" indent="0">
               <a:buNone/>
             </a:pPr>
             <a:r>
-              <a:t>1,000 synthetic org memories · 154 sloppy user queries · granite-embedding-311m</a:t>
+              <a:rPr sz="2000" b="1"/>
+              <a:t>Theme:</a:t>
+            </a:r>
+            <a:r>
+              <a:rPr sz="2000"/>
+              <a:t> the 311M model runs constantly so the 26B model runs rarely.</a:t>
             </a:r>
           </a:p>
         </p:txBody>
@@ -7441,6 +7621,79 @@
 </file>
 
 <file path=ppt/slides/slide20.xml><?xml version="1.0" encoding="utf-8"?>
+<p:sld xmlns:a="http://schemas.openxmlformats.org/drawingml/2006/main" xmlns:r="http://schemas.openxmlformats.org/officeDocument/2006/relationships" xmlns:p="http://schemas.openxmlformats.org/presentationml/2006/main">
+  <p:cSld>
+    <p:spTree>
+      <p:nvGrpSpPr>
+        <p:cNvPr id="1" name=""/>
+        <p:cNvGrpSpPr/>
+        <p:nvPr/>
+      </p:nvGrpSpPr>
+      <p:grpSpPr>
+        <a:xfrm>
+          <a:off x="0" y="0"/>
+          <a:ext cx="0" cy="0"/>
+          <a:chOff x="0" y="0"/>
+          <a:chExt cx="0" cy="0"/>
+        </a:xfrm>
+      </p:grpSpPr>
+      <p:sp>
+        <p:nvSpPr>
+          <p:cNvPr id="2" name="Title 1"/>
+          <p:cNvSpPr>
+            <a:spLocks noGrp="1"/>
+          </p:cNvSpPr>
+          <p:nvPr>
+            <p:ph type="title"/>
+          </p:nvPr>
+        </p:nvSpPr>
+        <p:spPr/>
+        <p:txBody>
+          <a:bodyPr/>
+          <a:lstStyle/>
+          <a:p>
+            <a:pPr marL="0" lvl="0" indent="0">
+              <a:buNone/>
+            </a:pPr>
+            <a:r>
+              <a:t>Measured: slot-key embedding leg</a:t>
+            </a:r>
+          </a:p>
+        </p:txBody>
+      </p:sp>
+      <p:sp>
+        <p:nvSpPr>
+          <p:cNvPr id="3" name="Content Placeholder 2"/>
+          <p:cNvSpPr>
+            <a:spLocks noGrp="1"/>
+          </p:cNvSpPr>
+          <p:nvPr>
+            <p:ph idx="1"/>
+          </p:nvPr>
+        </p:nvSpPr>
+        <p:spPr/>
+        <p:txBody>
+          <a:bodyPr/>
+          <a:lstStyle/>
+          <a:p>
+            <a:pPr marL="0" lvl="0" indent="0">
+              <a:buNone/>
+            </a:pPr>
+            <a:r>
+              <a:t>1,000 synthetic org memories · 154 sloppy user queries · granite-embedding-311m</a:t>
+            </a:r>
+          </a:p>
+        </p:txBody>
+      </p:sp>
+    </p:spTree>
+  </p:cSld>
+  <p:clrMapOvr>
+    <a:masterClrMapping/>
+  </p:clrMapOvr>
+</p:sld>
+</file>
+
+<file path=ppt/slides/slide21.xml><?xml version="1.0" encoding="utf-8"?>
 <p:sld xmlns:a="http://schemas.openxmlformats.org/drawingml/2006/main" xmlns:r="http://schemas.openxmlformats.org/officeDocument/2006/relationships" xmlns:p="http://schemas.openxmlformats.org/presentationml/2006/main">
   <p:cSld>
     <p:spTree>
@@ -7865,142 +8118,6 @@
 </p:sld>
 </file>
 
-<file path=ppt/slides/slide21.xml><?xml version="1.0" encoding="utf-8"?>
-<p:sld xmlns:a="http://schemas.openxmlformats.org/drawingml/2006/main" xmlns:r="http://schemas.openxmlformats.org/officeDocument/2006/relationships" xmlns:p="http://schemas.openxmlformats.org/presentationml/2006/main">
-  <p:cSld>
-    <p:spTree>
-      <p:nvGrpSpPr>
-        <p:cNvPr id="1" name=""/>
-        <p:cNvGrpSpPr/>
-        <p:nvPr/>
-      </p:nvGrpSpPr>
-      <p:grpSpPr>
-        <a:xfrm>
-          <a:off x="0" y="0"/>
-          <a:ext cx="0" cy="0"/>
-          <a:chOff x="0" y="0"/>
-          <a:chExt cx="0" cy="0"/>
-        </a:xfrm>
-      </p:grpSpPr>
-      <p:sp>
-        <p:nvSpPr>
-          <p:cNvPr id="2" name="Title 1"/>
-          <p:cNvSpPr>
-            <a:spLocks noGrp="1"/>
-          </p:cNvSpPr>
-          <p:nvPr>
-            <p:ph type="title"/>
-          </p:nvPr>
-        </p:nvSpPr>
-        <p:spPr/>
-        <p:txBody>
-          <a:bodyPr/>
-          <a:lstStyle/>
-          <a:p>
-            <a:pPr marL="0" lvl="0" indent="0">
-              <a:buNone/>
-            </a:pPr>
-            <a:r>
-              <a:t>The memory model</a:t>
-            </a:r>
-          </a:p>
-        </p:txBody>
-      </p:sp>
-      <p:sp>
-        <p:nvSpPr>
-          <p:cNvPr id="3" name="Content Placeholder 2"/>
-          <p:cNvSpPr>
-            <a:spLocks noGrp="1"/>
-          </p:cNvSpPr>
-          <p:nvPr>
-            <p:ph idx="1"/>
-          </p:nvPr>
-        </p:nvSpPr>
-        <p:spPr/>
-        <p:txBody>
-          <a:bodyPr>
-            <a:normAutofit fontScale="85000" lnSpcReduction="20000"/>
-          </a:bodyPr>
-          <a:lstStyle/>
-          <a:p>
-            <a:pPr lvl="0"/>
-            <a:r>
-              <a:t>Two scopes: </a:t>
-            </a:r>
-            <a:r>
-              <a:rPr b="1"/>
-              <a:t>user</a:t>
-            </a:r>
-            <a:r>
-              <a:t> (personal) and </a:t>
-            </a:r>
-            <a:r>
-              <a:rPr b="1"/>
-              <a:t>shared</a:t>
-            </a:r>
-            <a:r>
-              <a:t> (org) — fused into one search view</a:t>
-            </a:r>
-          </a:p>
-          <a:p>
-            <a:pPr lvl="0"/>
-            <a:r>
-              <a:t>Slot keys: canonical attributes (</a:t>
-            </a:r>
-            <a:r>
-              <a:rPr>
-                <a:latin typeface="Courier"/>
-              </a:rPr>
-              <a:t>organisation.name</a:t>
-            </a:r>
-            <a:r>
-              <a:t>) — idempotent writes, exact lookups</a:t>
-            </a:r>
-          </a:p>
-          <a:p>
-            <a:pPr lvl="0"/>
-            <a:r>
-              <a:t>Auto-extraction after each turn (background, preemptible), deduped against explicit writes</a:t>
-            </a:r>
-          </a:p>
-          <a:p>
-            <a:pPr lvl="0"/>
-            <a:r>
-              <a:t>Conflict detection on write: FTS+vector candidates → LLM judge, structured JSON, </a:t>
-            </a:r>
-            <a:r>
-              <a:rPr b="1"/>
-              <a:t>confidence ≥ 7 gate</a:t>
-            </a:r>
-          </a:p>
-          <a:p>
-            <a:pPr lvl="0"/>
-            <a:r>
-              <a:t>Provenance, TTL, pinning; cross-scope reconcile (an attribute can’t live in both scopes)</a:t>
-            </a:r>
-          </a:p>
-          <a:p>
-            <a:pPr lvl="0"/>
-            <a:r>
-              <a:t>Memory glob rendered into the system prompt; the rest recalled via </a:t>
-            </a:r>
-            <a:r>
-              <a:rPr>
-                <a:latin typeface="Courier"/>
-              </a:rPr>
-              <a:t>memory_search</a:t>
-            </a:r>
-          </a:p>
-        </p:txBody>
-      </p:sp>
-    </p:spTree>
-  </p:cSld>
-  <p:clrMapOvr>
-    <a:masterClrMapping/>
-  </p:clrMapOvr>
-</p:sld>
-</file>
-
 <file path=ppt/slides/slide22.xml><?xml version="1.0" encoding="utf-8"?>
 <p:sld xmlns:a="http://schemas.openxmlformats.org/drawingml/2006/main" xmlns:r="http://schemas.openxmlformats.org/officeDocument/2006/relationships" xmlns:p="http://schemas.openxmlformats.org/presentationml/2006/main">
   <p:cSld>
@@ -8033,21 +8150,11 @@
           <a:bodyPr/>
           <a:lstStyle/>
           <a:p>
-            <a:r>
-              <a:rPr dirty="0"/>
-              <a:t>Skill</a:t>
-            </a:r>
-            <a:r>
-              <a:rPr lang="hr-HR" dirty="0"/>
-              <a:t> </a:t>
-            </a:r>
-            <a:r>
-              <a:rPr lang="hr-HR" dirty="0" err="1"/>
-              <a:t>files</a:t>
-            </a:r>
-            <a:r>
-              <a:rPr dirty="0"/>
-              <a:t> are templated Markdown</a:t>
+            <a:pPr marL="0" lvl="0" indent="0">
+              <a:buNone/>
+            </a:pPr>
+            <a:r>
+              <a:t>The memory model</a:t>
             </a:r>
           </a:p>
         </p:txBody>
@@ -8059,280 +8166,82 @@
             <a:spLocks noGrp="1"/>
           </p:cNvSpPr>
           <p:nvPr>
-            <p:ph sz="half" idx="1"/>
+            <p:ph idx="1"/>
           </p:nvPr>
         </p:nvSpPr>
         <p:spPr/>
         <p:txBody>
-          <a:bodyPr wrap="square"/>
+          <a:bodyPr>
+            <a:normAutofit fontScale="85000" lnSpcReduction="20000"/>
+          </a:bodyPr>
           <a:lstStyle/>
           <a:p>
-            <a:r>
-              <a:rPr sz="1600" dirty="0"/>
-              <a:t>Every skill / hat / system-prompt .md is run through a sandboxed JS template before use</a:t>
-            </a:r>
-          </a:p>
-          <a:p>
-            <a:r>
-              <a:rPr sz="1600" dirty="0"/>
-              <a:t>&lt;?</a:t>
-            </a:r>
-            <a:r>
-              <a:rPr sz="1600" dirty="0" err="1"/>
-              <a:t>js</a:t>
-            </a:r>
-            <a:r>
-              <a:rPr sz="1600" dirty="0"/>
-              <a:t> ... ?&gt; blocks execute</a:t>
-            </a:r>
-            <a:r>
-              <a:rPr lang="hr-HR" sz="1600" dirty="0"/>
-              <a:t>JavaScript;</a:t>
-            </a:r>
-            <a:r>
-              <a:rPr sz="1600" dirty="0"/>
-              <a:t> print()/</a:t>
-            </a:r>
-            <a:r>
-              <a:rPr sz="1600" dirty="0" err="1"/>
-              <a:t>println</a:t>
-            </a:r>
-            <a:r>
-              <a:rPr sz="1600" dirty="0"/>
-              <a:t>() splice output in place</a:t>
-            </a:r>
-          </a:p>
-          <a:p>
-            <a:r>
-              <a:rPr sz="1600" dirty="0"/>
-              <a:t>Same per-user </a:t>
-            </a:r>
-            <a:r>
-              <a:rPr sz="1600" dirty="0" err="1"/>
-              <a:t>ctx</a:t>
-            </a:r>
-            <a:r>
-              <a:rPr sz="1600" dirty="0"/>
-              <a:t> everywhere: </a:t>
-            </a:r>
-            <a:r>
-              <a:rPr sz="1600" dirty="0" err="1"/>
-              <a:t>ctx.user</a:t>
-            </a:r>
-            <a:r>
-              <a:rPr sz="1600" dirty="0"/>
-              <a:t>, </a:t>
-            </a:r>
-            <a:r>
-              <a:rPr sz="1600" dirty="0" err="1"/>
-              <a:t>ctx.date</a:t>
-            </a:r>
-            <a:r>
-              <a:rPr sz="1600" dirty="0"/>
-              <a:t>, </a:t>
-            </a:r>
-            <a:r>
-              <a:rPr sz="1600" dirty="0" err="1"/>
-              <a:t>ctx.memoryGlob</a:t>
-            </a:r>
-            <a:r>
-              <a:rPr sz="1600" dirty="0"/>
-              <a:t>(g), </a:t>
-            </a:r>
-            <a:r>
-              <a:rPr sz="1600" dirty="0" err="1"/>
-              <a:t>ctx.memorySearch</a:t>
-            </a:r>
-            <a:r>
-              <a:rPr sz="1600" dirty="0"/>
-              <a:t>(q), </a:t>
-            </a:r>
-            <a:r>
-              <a:rPr sz="1600" dirty="0" err="1"/>
-              <a:t>ctx.searchDocs</a:t>
-            </a:r>
-            <a:r>
-              <a:rPr sz="1600" dirty="0"/>
-              <a:t>(q)</a:t>
-            </a:r>
-          </a:p>
-          <a:p>
-            <a:r>
-              <a:rPr sz="1600" dirty="0"/>
-              <a:t>Lets a static prompt pull in live state at render time</a:t>
-            </a:r>
-            <a:endParaRPr lang="hr-HR" sz="1600" dirty="0"/>
-          </a:p>
-          <a:p>
-            <a:r>
-              <a:rPr sz="1600" dirty="0"/>
-              <a:t>Fails closed: a JS error or timeout aborts the whole render</a:t>
-            </a:r>
-          </a:p>
-        </p:txBody>
-      </p:sp>
-      <p:sp>
-        <p:nvSpPr>
-          <p:cNvPr id="4" name="Content Placeholder 3"/>
-          <p:cNvSpPr>
-            <a:spLocks noGrp="1"/>
-          </p:cNvSpPr>
-          <p:nvPr>
-            <p:ph sz="half" idx="2"/>
-          </p:nvPr>
-        </p:nvSpPr>
-        <p:spPr/>
-        <p:txBody>
-          <a:bodyPr wrap="square"/>
-          <a:lstStyle/>
-          <a:p>
-            <a:r>
-              <a:rPr sz="1200">
-                <a:solidFill>
-                  <a:srgbClr val="333333"/>
-                </a:solidFill>
-                <a:latin typeface="Consolas"/>
+            <a:pPr lvl="0"/>
+            <a:r>
+              <a:t>Two scopes: </a:t>
+            </a:r>
+            <a:r>
+              <a:rPr b="1"/>
+              <a:t>user</a:t>
+            </a:r>
+            <a:r>
+              <a:t> (personal) and </a:t>
+            </a:r>
+            <a:r>
+              <a:rPr b="1"/>
+              <a:t>shared</a:t>
+            </a:r>
+            <a:r>
+              <a:t> (org) — fused into one search view</a:t>
+            </a:r>
+          </a:p>
+          <a:p>
+            <a:pPr lvl="0"/>
+            <a:r>
+              <a:t>Slot keys: canonical attributes (</a:t>
+            </a:r>
+            <a:r>
+              <a:rPr>
+                <a:latin typeface="Courier"/>
               </a:rPr>
-              <a:t>## What you know about the user</a:t>
-            </a:r>
-          </a:p>
-          <a:p>
-            <a:endParaRPr sz="1200">
-              <a:solidFill>
-                <a:srgbClr val="333333"/>
-              </a:solidFill>
-              <a:latin typeface="Consolas"/>
-            </a:endParaRPr>
-          </a:p>
-          <a:p>
-            <a:r>
-              <a:rPr sz="1200">
-                <a:solidFill>
-                  <a:srgbClr val="333333"/>
-                </a:solidFill>
-                <a:latin typeface="Consolas"/>
+              <a:t>organisation.name</a:t>
+            </a:r>
+            <a:r>
+              <a:t>) — idempotent writes, exact lookups</a:t>
+            </a:r>
+          </a:p>
+          <a:p>
+            <a:pPr lvl="0"/>
+            <a:r>
+              <a:t>Auto-extraction after each turn (background, preemptible), deduped against explicit writes</a:t>
+            </a:r>
+          </a:p>
+          <a:p>
+            <a:pPr lvl="0"/>
+            <a:r>
+              <a:t>Conflict detection on write: FTS+vector candidates → LLM judge, structured JSON, </a:t>
+            </a:r>
+            <a:r>
+              <a:rPr b="1"/>
+              <a:t>confidence ≥ 7 gate</a:t>
+            </a:r>
+          </a:p>
+          <a:p>
+            <a:pPr lvl="0"/>
+            <a:r>
+              <a:t>Provenance, TTL, pinning; cross-scope reconcile (an attribute can’t live in both scopes)</a:t>
+            </a:r>
+          </a:p>
+          <a:p>
+            <a:pPr lvl="0"/>
+            <a:r>
+              <a:t>Memory glob rendered into the system prompt; the rest recalled via </a:t>
+            </a:r>
+            <a:r>
+              <a:rPr>
+                <a:latin typeface="Courier"/>
               </a:rPr>
-              <a:t>&lt;?js</a:t>
-            </a:r>
-          </a:p>
-          <a:p>
-            <a:r>
-              <a:rPr sz="1200">
-                <a:solidFill>
-                  <a:srgbClr val="333333"/>
-                </a:solidFill>
-                <a:latin typeface="Consolas"/>
-              </a:rPr>
-              <a:t>var slots = ctx.memoryGlob("user.*");</a:t>
-            </a:r>
-          </a:p>
-          <a:p>
-            <a:r>
-              <a:rPr sz="1200">
-                <a:solidFill>
-                  <a:srgbClr val="333333"/>
-                </a:solidFill>
-                <a:latin typeface="Consolas"/>
-              </a:rPr>
-              <a:t>if (slots.length &gt; 0) {</a:t>
-            </a:r>
-          </a:p>
-          <a:p>
-            <a:r>
-              <a:rPr sz="1200">
-                <a:solidFill>
-                  <a:srgbClr val="333333"/>
-                </a:solidFill>
-                <a:latin typeface="Consolas"/>
-              </a:rPr>
-              <a:t>  for (var i = 0; i &lt; slots.length; i++) {</a:t>
-            </a:r>
-          </a:p>
-          <a:p>
-            <a:r>
-              <a:rPr sz="1200">
-                <a:solidFill>
-                  <a:srgbClr val="333333"/>
-                </a:solidFill>
-                <a:latin typeface="Consolas"/>
-              </a:rPr>
-              <a:t>    println("- " + slots[i].key +</a:t>
-            </a:r>
-          </a:p>
-          <a:p>
-            <a:r>
-              <a:rPr sz="1200">
-                <a:solidFill>
-                  <a:srgbClr val="333333"/>
-                </a:solidFill>
-                <a:latin typeface="Consolas"/>
-              </a:rPr>
-              <a:t>            ": " + slots[i].content);</a:t>
-            </a:r>
-          </a:p>
-          <a:p>
-            <a:r>
-              <a:rPr sz="1200">
-                <a:solidFill>
-                  <a:srgbClr val="333333"/>
-                </a:solidFill>
-                <a:latin typeface="Consolas"/>
-              </a:rPr>
-              <a:t>  }</a:t>
-            </a:r>
-          </a:p>
-          <a:p>
-            <a:r>
-              <a:rPr sz="1200">
-                <a:solidFill>
-                  <a:srgbClr val="333333"/>
-                </a:solidFill>
-                <a:latin typeface="Consolas"/>
-              </a:rPr>
-              <a:t>} else {</a:t>
-            </a:r>
-          </a:p>
-          <a:p>
-            <a:r>
-              <a:rPr sz="1200">
-                <a:solidFill>
-                  <a:srgbClr val="333333"/>
-                </a:solidFill>
-                <a:latin typeface="Consolas"/>
-              </a:rPr>
-              <a:t>  println("- (nothing stored yet)");</a:t>
-            </a:r>
-          </a:p>
-          <a:p>
-            <a:r>
-              <a:rPr sz="1200">
-                <a:solidFill>
-                  <a:srgbClr val="333333"/>
-                </a:solidFill>
-                <a:latin typeface="Consolas"/>
-              </a:rPr>
-              <a:t>}</a:t>
-            </a:r>
-          </a:p>
-          <a:p>
-            <a:r>
-              <a:rPr sz="1200">
-                <a:solidFill>
-                  <a:srgbClr val="333333"/>
-                </a:solidFill>
-                <a:latin typeface="Consolas"/>
-              </a:rPr>
-              <a:t>?&gt;</a:t>
-            </a:r>
-          </a:p>
-          <a:p>
-            <a:r>
-              <a:rPr sz="1000" i="1">
-                <a:solidFill>
-                  <a:srgbClr val="888888"/>
-                </a:solidFill>
-              </a:rPr>
-              <a:t>— skills/system_prompt.md (excerpt)</a:t>
+              <a:t>memory_search</a:t>
             </a:r>
           </a:p>
         </p:txBody>
@@ -8377,54 +8286,9 @@
           <a:bodyPr/>
           <a:lstStyle/>
           <a:p>
-            <a:pPr marL="0" lvl="0" indent="0">
-              <a:buNone/>
-            </a:pPr>
-            <a:r>
-              <a:t>Hats</a:t>
-            </a:r>
-          </a:p>
-        </p:txBody>
-      </p:sp>
-      <p:sp>
-        <p:nvSpPr>
-          <p:cNvPr id="3" name="Content Placeholder 2"/>
-          <p:cNvSpPr>
-            <a:spLocks noGrp="1"/>
-          </p:cNvSpPr>
-          <p:nvPr>
-            <p:ph idx="1"/>
-          </p:nvPr>
-        </p:nvSpPr>
-        <p:spPr/>
-        <p:txBody>
-          <a:bodyPr>
-            <a:normAutofit fontScale="92500" lnSpcReduction="20000"/>
-          </a:bodyPr>
-          <a:lstStyle/>
-          <a:p>
-            <a:pPr marL="0" lvl="0" indent="0">
-              <a:buNone/>
-            </a:pPr>
             <a:r>
               <a:rPr dirty="0"/>
-              <a:t>A </a:t>
-            </a:r>
-            <a:r>
-              <a:rPr b="1" dirty="0"/>
-              <a:t>hat</a:t>
-            </a:r>
-            <a:r>
-              <a:rPr dirty="0"/>
-              <a:t> = persona per conversation</a:t>
-            </a:r>
-            <a:r>
-              <a:rPr lang="hr-HR" dirty="0"/>
-              <a:t> („</a:t>
-            </a:r>
-            <a:r>
-              <a:rPr lang="hr-HR" dirty="0" err="1"/>
-              <a:t>wearing</a:t>
+              <a:t>Skill</a:t>
             </a:r>
             <a:r>
               <a:rPr lang="hr-HR" dirty="0"/>
@@ -8432,311 +8296,296 @@
             </a:r>
             <a:r>
               <a:rPr lang="hr-HR" dirty="0" err="1"/>
-              <a:t>the</a:t>
-            </a:r>
-            <a:r>
-              <a:rPr lang="hr-HR" dirty="0"/>
-              <a:t> </a:t>
-            </a:r>
-            <a:r>
-              <a:rPr lang="hr-HR" dirty="0" err="1"/>
-              <a:t>hat</a:t>
-            </a:r>
-            <a:r>
-              <a:rPr lang="hr-HR" dirty="0"/>
-              <a:t> </a:t>
-            </a:r>
-            <a:r>
-              <a:rPr lang="hr-HR" dirty="0" err="1"/>
-              <a:t>of</a:t>
-            </a:r>
-            <a:r>
-              <a:rPr lang="hr-HR" dirty="0"/>
-              <a:t> </a:t>
-            </a:r>
-            <a:r>
-              <a:rPr lang="hr-HR" dirty="0" err="1"/>
-              <a:t>an</a:t>
-            </a:r>
-            <a:r>
-              <a:rPr lang="hr-HR" dirty="0"/>
-              <a:t> </a:t>
-            </a:r>
-            <a:r>
-              <a:rPr lang="hr-HR" dirty="0" err="1"/>
-              <a:t>account</a:t>
-            </a:r>
-            <a:r>
-              <a:rPr lang="hr-HR" dirty="0"/>
-              <a:t> manager, I do X”)</a:t>
+              <a:t>files</a:t>
             </a:r>
             <a:r>
               <a:rPr dirty="0"/>
-              <a:t>: own system prompt + curated skill set</a:t>
-            </a:r>
-          </a:p>
-          <a:p>
-            <a:pPr lvl="0" indent="0">
-              <a:buNone/>
-            </a:pPr>
-            <a:r>
-              <a:rPr dirty="0">
+              <a:t> are templated Markdown</a:t>
+            </a:r>
+          </a:p>
+        </p:txBody>
+      </p:sp>
+      <p:sp>
+        <p:nvSpPr>
+          <p:cNvPr id="3" name="Content Placeholder 2"/>
+          <p:cNvSpPr>
+            <a:spLocks noGrp="1"/>
+          </p:cNvSpPr>
+          <p:nvPr>
+            <p:ph sz="half" idx="1"/>
+          </p:nvPr>
+        </p:nvSpPr>
+        <p:spPr/>
+        <p:txBody>
+          <a:bodyPr wrap="square"/>
+          <a:lstStyle/>
+          <a:p>
+            <a:r>
+              <a:rPr sz="1600" dirty="0"/>
+              <a:t>Every skill / hat / system-prompt .md is run through a sandboxed JS template before use</a:t>
+            </a:r>
+          </a:p>
+          <a:p>
+            <a:r>
+              <a:rPr sz="1600" dirty="0"/>
+              <a:t>&lt;?</a:t>
+            </a:r>
+            <a:r>
+              <a:rPr sz="1600" dirty="0" err="1"/>
+              <a:t>js</a:t>
+            </a:r>
+            <a:r>
+              <a:rPr sz="1600" dirty="0"/>
+              <a:t> ... ?&gt; blocks execute</a:t>
+            </a:r>
+            <a:r>
+              <a:rPr lang="hr-HR" sz="1600" dirty="0"/>
+              <a:t>JavaScript;</a:t>
+            </a:r>
+            <a:r>
+              <a:rPr sz="1600" dirty="0"/>
+              <a:t> print()/</a:t>
+            </a:r>
+            <a:r>
+              <a:rPr sz="1600" dirty="0" err="1"/>
+              <a:t>println</a:t>
+            </a:r>
+            <a:r>
+              <a:rPr sz="1600" dirty="0"/>
+              <a:t>() splice output in place</a:t>
+            </a:r>
+          </a:p>
+          <a:p>
+            <a:r>
+              <a:rPr sz="1600" dirty="0"/>
+              <a:t>Same per-user </a:t>
+            </a:r>
+            <a:r>
+              <a:rPr sz="1600" dirty="0" err="1"/>
+              <a:t>ctx</a:t>
+            </a:r>
+            <a:r>
+              <a:rPr sz="1600" dirty="0"/>
+              <a:t> everywhere: </a:t>
+            </a:r>
+            <a:r>
+              <a:rPr sz="1600" dirty="0" err="1"/>
+              <a:t>ctx.user</a:t>
+            </a:r>
+            <a:r>
+              <a:rPr sz="1600" dirty="0"/>
+              <a:t>, </a:t>
+            </a:r>
+            <a:r>
+              <a:rPr sz="1600" dirty="0" err="1"/>
+              <a:t>ctx.date</a:t>
+            </a:r>
+            <a:r>
+              <a:rPr sz="1600" dirty="0"/>
+              <a:t>, </a:t>
+            </a:r>
+            <a:r>
+              <a:rPr sz="1600" dirty="0" err="1"/>
+              <a:t>ctx.memoryGlob</a:t>
+            </a:r>
+            <a:r>
+              <a:rPr sz="1600" dirty="0"/>
+              <a:t>(g), </a:t>
+            </a:r>
+            <a:r>
+              <a:rPr sz="1600" dirty="0" err="1"/>
+              <a:t>ctx.memorySearch</a:t>
+            </a:r>
+            <a:r>
+              <a:rPr sz="1600" dirty="0"/>
+              <a:t>(q), </a:t>
+            </a:r>
+            <a:r>
+              <a:rPr sz="1600" dirty="0" err="1"/>
+              <a:t>ctx.searchDocs</a:t>
+            </a:r>
+            <a:r>
+              <a:rPr sz="1600" dirty="0"/>
+              <a:t>(q)</a:t>
+            </a:r>
+          </a:p>
+          <a:p>
+            <a:r>
+              <a:rPr sz="1600" dirty="0"/>
+              <a:t>Lets a static prompt pull in live state at render time</a:t>
+            </a:r>
+            <a:endParaRPr lang="hr-HR" sz="1600" dirty="0"/>
+          </a:p>
+          <a:p>
+            <a:r>
+              <a:rPr sz="1600" dirty="0"/>
+              <a:t>Fails closed: a JS error or timeout aborts the whole render</a:t>
+            </a:r>
+          </a:p>
+        </p:txBody>
+      </p:sp>
+      <p:sp>
+        <p:nvSpPr>
+          <p:cNvPr id="4" name="Content Placeholder 3"/>
+          <p:cNvSpPr>
+            <a:spLocks noGrp="1"/>
+          </p:cNvSpPr>
+          <p:nvPr>
+            <p:ph sz="half" idx="2"/>
+          </p:nvPr>
+        </p:nvSpPr>
+        <p:spPr/>
+        <p:txBody>
+          <a:bodyPr wrap="square"/>
+          <a:lstStyle/>
+          <a:p>
+            <a:r>
+              <a:rPr sz="1200">
                 <a:solidFill>
-                  <a:srgbClr val="BC7A00"/>
+                  <a:srgbClr val="333333"/>
                 </a:solidFill>
-                <a:latin typeface="Courier"/>
+                <a:latin typeface="Consolas"/>
               </a:rPr>
-              <a:t>---</a:t>
-            </a:r>
-            <a:br>
-              <a:rPr dirty="0"/>
-            </a:br>
-            <a:r>
-              <a:rPr dirty="0">
+              <a:t>## What you know about the user</a:t>
+            </a:r>
+          </a:p>
+          <a:p>
+            <a:endParaRPr sz="1200">
+              <a:solidFill>
+                <a:srgbClr val="333333"/>
+              </a:solidFill>
+              <a:latin typeface="Consolas"/>
+            </a:endParaRPr>
+          </a:p>
+          <a:p>
+            <a:r>
+              <a:rPr sz="1200">
                 <a:solidFill>
-                  <a:srgbClr val="06287E"/>
+                  <a:srgbClr val="333333"/>
                 </a:solidFill>
-                <a:latin typeface="Courier"/>
+                <a:latin typeface="Consolas"/>
               </a:rPr>
-              <a:t>description</a:t>
-            </a:r>
-            <a:r>
-              <a:rPr b="1" dirty="0">
+              <a:t>&lt;?js</a:t>
+            </a:r>
+          </a:p>
+          <a:p>
+            <a:r>
+              <a:rPr sz="1200">
                 <a:solidFill>
-                  <a:srgbClr val="007020"/>
+                  <a:srgbClr val="333333"/>
                 </a:solidFill>
-                <a:latin typeface="Courier"/>
+                <a:latin typeface="Consolas"/>
               </a:rPr>
-              <a:t>:</a:t>
-            </a:r>
-            <a:r>
-              <a:rPr dirty="0">
+              <a:t>var slots = ctx.memoryGlob("user.*");</a:t>
+            </a:r>
+          </a:p>
+          <a:p>
+            <a:r>
+              <a:rPr sz="1200">
                 <a:solidFill>
-                  <a:srgbClr val="7D9029"/>
+                  <a:srgbClr val="333333"/>
                 </a:solidFill>
-                <a:latin typeface="Courier"/>
+                <a:latin typeface="Consolas"/>
               </a:rPr>
-              <a:t> Maintains the </a:t>
-            </a:r>
-            <a:r>
-              <a:rPr dirty="0" err="1">
+              <a:t>if (slots.length &gt; 0) {</a:t>
+            </a:r>
+          </a:p>
+          <a:p>
+            <a:r>
+              <a:rPr sz="1200">
                 <a:solidFill>
-                  <a:srgbClr val="7D9029"/>
+                  <a:srgbClr val="333333"/>
                 </a:solidFill>
-                <a:latin typeface="Courier"/>
+                <a:latin typeface="Consolas"/>
               </a:rPr>
-              <a:t>organisation's</a:t>
-            </a:r>
-            <a:r>
-              <a:rPr dirty="0">
+              <a:t>  for (var i = 0; i &lt; slots.length; i++) {</a:t>
+            </a:r>
+          </a:p>
+          <a:p>
+            <a:r>
+              <a:rPr sz="1200">
                 <a:solidFill>
-                  <a:srgbClr val="7D9029"/>
+                  <a:srgbClr val="333333"/>
                 </a:solidFill>
-                <a:latin typeface="Courier"/>
+                <a:latin typeface="Consolas"/>
               </a:rPr>
-              <a:t> website.</a:t>
-            </a:r>
-            <a:br>
-              <a:rPr dirty="0"/>
-            </a:br>
-            <a:r>
-              <a:rPr dirty="0">
+              <a:t>    println("- " + slots[i].key +</a:t>
+            </a:r>
+          </a:p>
+          <a:p>
+            <a:r>
+              <a:rPr sz="1200">
                 <a:solidFill>
-                  <a:srgbClr val="06287E"/>
+                  <a:srgbClr val="333333"/>
                 </a:solidFill>
-                <a:latin typeface="Courier"/>
+                <a:latin typeface="Consolas"/>
               </a:rPr>
-              <a:t>skills</a:t>
-            </a:r>
-            <a:r>
-              <a:rPr b="1" dirty="0">
+              <a:t>            ": " + slots[i].content);</a:t>
+            </a:r>
+          </a:p>
+          <a:p>
+            <a:r>
+              <a:rPr sz="1200">
                 <a:solidFill>
-                  <a:srgbClr val="007020"/>
+                  <a:srgbClr val="333333"/>
                 </a:solidFill>
-                <a:latin typeface="Courier"/>
+                <a:latin typeface="Consolas"/>
               </a:rPr>
-              <a:t>:</a:t>
-            </a:r>
-            <a:r>
-              <a:rPr dirty="0">
+              <a:t>  }</a:t>
+            </a:r>
+          </a:p>
+          <a:p>
+            <a:r>
+              <a:rPr sz="1200">
                 <a:solidFill>
-                  <a:srgbClr val="7D9029"/>
+                  <a:srgbClr val="333333"/>
                 </a:solidFill>
-                <a:latin typeface="Courier"/>
+                <a:latin typeface="Consolas"/>
               </a:rPr>
-              <a:t> </a:t>
-            </a:r>
-            <a:r>
-              <a:rPr b="1" dirty="0">
+              <a:t>} else {</a:t>
+            </a:r>
+          </a:p>
+          <a:p>
+            <a:r>
+              <a:rPr sz="1200">
                 <a:solidFill>
-                  <a:srgbClr val="007020"/>
+                  <a:srgbClr val="333333"/>
                 </a:solidFill>
-                <a:latin typeface="Courier"/>
+                <a:latin typeface="Consolas"/>
               </a:rPr>
-              <a:t>[</a:t>
-            </a:r>
-            <a:r>
-              <a:rPr dirty="0">
+              <a:t>  println("- (nothing stored yet)");</a:t>
+            </a:r>
+          </a:p>
+          <a:p>
+            <a:r>
+              <a:rPr sz="1200">
                 <a:solidFill>
-                  <a:srgbClr val="7D9029"/>
+                  <a:srgbClr val="333333"/>
                 </a:solidFill>
-                <a:latin typeface="Courier"/>
+                <a:latin typeface="Consolas"/>
               </a:rPr>
-              <a:t>example-greeter</a:t>
-            </a:r>
-            <a:r>
-              <a:rPr b="1" dirty="0">
+              <a:t>}</a:t>
+            </a:r>
+          </a:p>
+          <a:p>
+            <a:r>
+              <a:rPr sz="1200">
                 <a:solidFill>
-                  <a:srgbClr val="007020"/>
+                  <a:srgbClr val="333333"/>
                 </a:solidFill>
-                <a:latin typeface="Courier"/>
+                <a:latin typeface="Consolas"/>
               </a:rPr>
-              <a:t>]</a:t>
-            </a:r>
-            <a:br>
-              <a:rPr dirty="0"/>
-            </a:br>
-            <a:r>
-              <a:rPr dirty="0">
+              <a:t>?&gt;</a:t>
+            </a:r>
+          </a:p>
+          <a:p>
+            <a:r>
+              <a:rPr sz="1000" i="1">
                 <a:solidFill>
-                  <a:srgbClr val="BC7A00"/>
+                  <a:srgbClr val="888888"/>
                 </a:solidFill>
-                <a:latin typeface="Courier"/>
               </a:rPr>
-              <a:t>---</a:t>
-            </a:r>
-            <a:br>
-              <a:rPr dirty="0"/>
-            </a:br>
-            <a:r>
-              <a:rPr dirty="0">
-                <a:solidFill>
-                  <a:srgbClr val="7D9029"/>
-                </a:solidFill>
-                <a:latin typeface="Courier"/>
-              </a:rPr>
-              <a:t>You are Harlequin acting as the </a:t>
-            </a:r>
-            <a:r>
-              <a:rPr dirty="0" err="1">
-                <a:solidFill>
-                  <a:srgbClr val="7D9029"/>
-                </a:solidFill>
-                <a:latin typeface="Courier"/>
-              </a:rPr>
-              <a:t>organisation's</a:t>
-            </a:r>
-            <a:r>
-              <a:rPr dirty="0">
-                <a:solidFill>
-                  <a:srgbClr val="7D9029"/>
-                </a:solidFill>
-                <a:latin typeface="Courier"/>
-              </a:rPr>
-              <a:t> **webmaster**…</a:t>
-            </a:r>
-          </a:p>
-          <a:p>
-            <a:pPr lvl="0"/>
-            <a:r>
-              <a:rPr lang="hr-HR" dirty="0" err="1"/>
-              <a:t>Hats</a:t>
-            </a:r>
-            <a:r>
-              <a:rPr lang="hr-HR" dirty="0"/>
-              <a:t> </a:t>
-            </a:r>
-            <a:r>
-              <a:rPr lang="hr-HR" dirty="0" err="1"/>
-              <a:t>can</a:t>
-            </a:r>
-            <a:r>
-              <a:rPr lang="hr-HR" dirty="0"/>
-              <a:t> </a:t>
-            </a:r>
-            <a:r>
-              <a:rPr lang="hr-HR" dirty="0" err="1"/>
-              <a:t>override</a:t>
-            </a:r>
-            <a:r>
-              <a:rPr lang="hr-HR" dirty="0"/>
-              <a:t> </a:t>
-            </a:r>
-            <a:r>
-              <a:rPr lang="hr-HR" dirty="0" err="1"/>
-              <a:t>the</a:t>
-            </a:r>
-            <a:r>
-              <a:rPr lang="hr-HR" dirty="0"/>
-              <a:t> </a:t>
-            </a:r>
-            <a:r>
-              <a:rPr lang="hr-HR" dirty="0" err="1"/>
-              <a:t>sets</a:t>
-            </a:r>
-            <a:r>
-              <a:rPr lang="hr-HR" dirty="0"/>
-              <a:t> </a:t>
-            </a:r>
-            <a:r>
-              <a:rPr lang="hr-HR" dirty="0" err="1"/>
-              <a:t>of</a:t>
-            </a:r>
-            <a:r>
-              <a:rPr lang="hr-HR" dirty="0"/>
-              <a:t> </a:t>
-            </a:r>
-            <a:r>
-              <a:rPr lang="hr-HR" dirty="0" err="1"/>
-              <a:t>tools</a:t>
-            </a:r>
-            <a:r>
-              <a:rPr lang="hr-HR" dirty="0"/>
-              <a:t>, </a:t>
-            </a:r>
-            <a:r>
-              <a:rPr lang="hr-HR" dirty="0" err="1"/>
-              <a:t>skills</a:t>
-            </a:r>
-            <a:r>
-              <a:rPr lang="hr-HR" dirty="0"/>
-              <a:t> </a:t>
-            </a:r>
-            <a:r>
-              <a:rPr lang="hr-HR" dirty="0" err="1"/>
-              <a:t>and</a:t>
-            </a:r>
-            <a:r>
-              <a:rPr lang="hr-HR" dirty="0"/>
-              <a:t> </a:t>
-            </a:r>
-            <a:r>
-              <a:rPr lang="hr-HR" dirty="0" err="1"/>
-              <a:t>the</a:t>
-            </a:r>
-            <a:r>
-              <a:rPr lang="hr-HR" dirty="0"/>
-              <a:t> system </a:t>
-            </a:r>
-            <a:r>
-              <a:rPr lang="hr-HR" dirty="0" err="1"/>
-              <a:t>prompt</a:t>
-            </a:r>
-            <a:endParaRPr dirty="0"/>
-          </a:p>
-          <a:p>
-            <a:pPr lvl="0"/>
-            <a:r>
-              <a:rPr dirty="0"/>
-              <a:t>Keeps the </a:t>
-            </a:r>
-            <a:r>
-              <a:rPr b="1" dirty="0"/>
-              <a:t>default</a:t>
-            </a:r>
-            <a:r>
-              <a:rPr dirty="0"/>
-              <a:t> prompt small — important when PP costs 95 s</a:t>
+              <a:t>— skills/system_prompt.md (excerpt)</a:t>
             </a:r>
           </a:p>
         </p:txBody>
@@ -8750,6 +8599,410 @@
 </file>
 
 <file path=ppt/slides/slide24.xml><?xml version="1.0" encoding="utf-8"?>
+<p:sld xmlns:a="http://schemas.openxmlformats.org/drawingml/2006/main" xmlns:r="http://schemas.openxmlformats.org/officeDocument/2006/relationships" xmlns:p="http://schemas.openxmlformats.org/presentationml/2006/main">
+  <p:cSld>
+    <p:spTree>
+      <p:nvGrpSpPr>
+        <p:cNvPr id="1" name=""/>
+        <p:cNvGrpSpPr/>
+        <p:nvPr/>
+      </p:nvGrpSpPr>
+      <p:grpSpPr>
+        <a:xfrm>
+          <a:off x="0" y="0"/>
+          <a:ext cx="0" cy="0"/>
+          <a:chOff x="0" y="0"/>
+          <a:chExt cx="0" cy="0"/>
+        </a:xfrm>
+      </p:grpSpPr>
+      <p:sp>
+        <p:nvSpPr>
+          <p:cNvPr id="2" name="Title 1"/>
+          <p:cNvSpPr>
+            <a:spLocks noGrp="1"/>
+          </p:cNvSpPr>
+          <p:nvPr>
+            <p:ph type="title"/>
+          </p:nvPr>
+        </p:nvSpPr>
+        <p:spPr/>
+        <p:txBody>
+          <a:bodyPr/>
+          <a:lstStyle/>
+          <a:p>
+            <a:pPr marL="0" lvl="0" indent="0">
+              <a:buNone/>
+            </a:pPr>
+            <a:r>
+              <a:t>Hats</a:t>
+            </a:r>
+          </a:p>
+        </p:txBody>
+      </p:sp>
+      <p:sp>
+        <p:nvSpPr>
+          <p:cNvPr id="3" name="Content Placeholder 2"/>
+          <p:cNvSpPr>
+            <a:spLocks noGrp="1"/>
+          </p:cNvSpPr>
+          <p:nvPr>
+            <p:ph idx="1"/>
+          </p:nvPr>
+        </p:nvSpPr>
+        <p:spPr/>
+        <p:txBody>
+          <a:bodyPr>
+            <a:normAutofit fontScale="92500" lnSpcReduction="20000"/>
+          </a:bodyPr>
+          <a:lstStyle/>
+          <a:p>
+            <a:pPr marL="0" lvl="0" indent="0">
+              <a:buNone/>
+            </a:pPr>
+            <a:r>
+              <a:rPr dirty="0"/>
+              <a:t>A </a:t>
+            </a:r>
+            <a:r>
+              <a:rPr b="1" dirty="0"/>
+              <a:t>hat</a:t>
+            </a:r>
+            <a:r>
+              <a:rPr dirty="0"/>
+              <a:t> = persona per conversation</a:t>
+            </a:r>
+            <a:r>
+              <a:rPr lang="hr-HR" dirty="0"/>
+              <a:t> („</a:t>
+            </a:r>
+            <a:r>
+              <a:rPr lang="hr-HR" dirty="0" err="1"/>
+              <a:t>wearing</a:t>
+            </a:r>
+            <a:r>
+              <a:rPr lang="hr-HR" dirty="0"/>
+              <a:t> </a:t>
+            </a:r>
+            <a:r>
+              <a:rPr lang="hr-HR" dirty="0" err="1"/>
+              <a:t>the</a:t>
+            </a:r>
+            <a:r>
+              <a:rPr lang="hr-HR" dirty="0"/>
+              <a:t> </a:t>
+            </a:r>
+            <a:r>
+              <a:rPr lang="hr-HR" dirty="0" err="1"/>
+              <a:t>hat</a:t>
+            </a:r>
+            <a:r>
+              <a:rPr lang="hr-HR" dirty="0"/>
+              <a:t> </a:t>
+            </a:r>
+            <a:r>
+              <a:rPr lang="hr-HR" dirty="0" err="1"/>
+              <a:t>of</a:t>
+            </a:r>
+            <a:r>
+              <a:rPr lang="hr-HR" dirty="0"/>
+              <a:t> </a:t>
+            </a:r>
+            <a:r>
+              <a:rPr lang="hr-HR" dirty="0" err="1"/>
+              <a:t>an</a:t>
+            </a:r>
+            <a:r>
+              <a:rPr lang="hr-HR" dirty="0"/>
+              <a:t> </a:t>
+            </a:r>
+            <a:r>
+              <a:rPr lang="hr-HR" dirty="0" err="1"/>
+              <a:t>account</a:t>
+            </a:r>
+            <a:r>
+              <a:rPr lang="hr-HR" dirty="0"/>
+              <a:t> manager, I do X”)</a:t>
+            </a:r>
+            <a:r>
+              <a:rPr dirty="0"/>
+              <a:t>: own system prompt + curated skill set</a:t>
+            </a:r>
+          </a:p>
+          <a:p>
+            <a:pPr lvl="0" indent="0">
+              <a:buNone/>
+            </a:pPr>
+            <a:r>
+              <a:rPr dirty="0">
+                <a:solidFill>
+                  <a:srgbClr val="BC7A00"/>
+                </a:solidFill>
+                <a:latin typeface="Courier"/>
+              </a:rPr>
+              <a:t>---</a:t>
+            </a:r>
+            <a:br>
+              <a:rPr dirty="0"/>
+            </a:br>
+            <a:r>
+              <a:rPr dirty="0">
+                <a:solidFill>
+                  <a:srgbClr val="06287E"/>
+                </a:solidFill>
+                <a:latin typeface="Courier"/>
+              </a:rPr>
+              <a:t>description</a:t>
+            </a:r>
+            <a:r>
+              <a:rPr b="1" dirty="0">
+                <a:solidFill>
+                  <a:srgbClr val="007020"/>
+                </a:solidFill>
+                <a:latin typeface="Courier"/>
+              </a:rPr>
+              <a:t>:</a:t>
+            </a:r>
+            <a:r>
+              <a:rPr dirty="0">
+                <a:solidFill>
+                  <a:srgbClr val="7D9029"/>
+                </a:solidFill>
+                <a:latin typeface="Courier"/>
+              </a:rPr>
+              <a:t> Maintains the </a:t>
+            </a:r>
+            <a:r>
+              <a:rPr dirty="0" err="1">
+                <a:solidFill>
+                  <a:srgbClr val="7D9029"/>
+                </a:solidFill>
+                <a:latin typeface="Courier"/>
+              </a:rPr>
+              <a:t>organisation's</a:t>
+            </a:r>
+            <a:r>
+              <a:rPr dirty="0">
+                <a:solidFill>
+                  <a:srgbClr val="7D9029"/>
+                </a:solidFill>
+                <a:latin typeface="Courier"/>
+              </a:rPr>
+              <a:t> website.</a:t>
+            </a:r>
+            <a:br>
+              <a:rPr dirty="0"/>
+            </a:br>
+            <a:r>
+              <a:rPr dirty="0">
+                <a:solidFill>
+                  <a:srgbClr val="06287E"/>
+                </a:solidFill>
+                <a:latin typeface="Courier"/>
+              </a:rPr>
+              <a:t>skills</a:t>
+            </a:r>
+            <a:r>
+              <a:rPr b="1" dirty="0">
+                <a:solidFill>
+                  <a:srgbClr val="007020"/>
+                </a:solidFill>
+                <a:latin typeface="Courier"/>
+              </a:rPr>
+              <a:t>:</a:t>
+            </a:r>
+            <a:r>
+              <a:rPr dirty="0">
+                <a:solidFill>
+                  <a:srgbClr val="7D9029"/>
+                </a:solidFill>
+                <a:latin typeface="Courier"/>
+              </a:rPr>
+              <a:t> </a:t>
+            </a:r>
+            <a:r>
+              <a:rPr b="1" dirty="0">
+                <a:solidFill>
+                  <a:srgbClr val="007020"/>
+                </a:solidFill>
+                <a:latin typeface="Courier"/>
+              </a:rPr>
+              <a:t>[</a:t>
+            </a:r>
+            <a:r>
+              <a:rPr dirty="0">
+                <a:solidFill>
+                  <a:srgbClr val="7D9029"/>
+                </a:solidFill>
+                <a:latin typeface="Courier"/>
+              </a:rPr>
+              <a:t>example-greeter</a:t>
+            </a:r>
+            <a:r>
+              <a:rPr b="1" dirty="0">
+                <a:solidFill>
+                  <a:srgbClr val="007020"/>
+                </a:solidFill>
+                <a:latin typeface="Courier"/>
+              </a:rPr>
+              <a:t>]</a:t>
+            </a:r>
+            <a:br>
+              <a:rPr dirty="0"/>
+            </a:br>
+            <a:r>
+              <a:rPr dirty="0">
+                <a:solidFill>
+                  <a:srgbClr val="BC7A00"/>
+                </a:solidFill>
+                <a:latin typeface="Courier"/>
+              </a:rPr>
+              <a:t>---</a:t>
+            </a:r>
+            <a:br>
+              <a:rPr dirty="0"/>
+            </a:br>
+            <a:r>
+              <a:rPr dirty="0">
+                <a:solidFill>
+                  <a:srgbClr val="7D9029"/>
+                </a:solidFill>
+                <a:latin typeface="Courier"/>
+              </a:rPr>
+              <a:t>You are Harlequin acting as the </a:t>
+            </a:r>
+            <a:r>
+              <a:rPr dirty="0" err="1">
+                <a:solidFill>
+                  <a:srgbClr val="7D9029"/>
+                </a:solidFill>
+                <a:latin typeface="Courier"/>
+              </a:rPr>
+              <a:t>organisation's</a:t>
+            </a:r>
+            <a:r>
+              <a:rPr dirty="0">
+                <a:solidFill>
+                  <a:srgbClr val="7D9029"/>
+                </a:solidFill>
+                <a:latin typeface="Courier"/>
+              </a:rPr>
+              <a:t> **webmaster**…</a:t>
+            </a:r>
+          </a:p>
+          <a:p>
+            <a:pPr lvl="0"/>
+            <a:r>
+              <a:rPr lang="hr-HR" dirty="0" err="1"/>
+              <a:t>Hats</a:t>
+            </a:r>
+            <a:r>
+              <a:rPr lang="hr-HR" dirty="0"/>
+              <a:t> </a:t>
+            </a:r>
+            <a:r>
+              <a:rPr lang="hr-HR" dirty="0" err="1"/>
+              <a:t>can</a:t>
+            </a:r>
+            <a:r>
+              <a:rPr lang="hr-HR" dirty="0"/>
+              <a:t> </a:t>
+            </a:r>
+            <a:r>
+              <a:rPr lang="hr-HR" dirty="0" err="1"/>
+              <a:t>override</a:t>
+            </a:r>
+            <a:r>
+              <a:rPr lang="hr-HR" dirty="0"/>
+              <a:t> </a:t>
+            </a:r>
+            <a:r>
+              <a:rPr lang="hr-HR" dirty="0" err="1"/>
+              <a:t>the</a:t>
+            </a:r>
+            <a:r>
+              <a:rPr lang="hr-HR" dirty="0"/>
+              <a:t> </a:t>
+            </a:r>
+            <a:r>
+              <a:rPr lang="hr-HR" dirty="0" err="1"/>
+              <a:t>sets</a:t>
+            </a:r>
+            <a:r>
+              <a:rPr lang="hr-HR" dirty="0"/>
+              <a:t> </a:t>
+            </a:r>
+            <a:r>
+              <a:rPr lang="hr-HR" dirty="0" err="1"/>
+              <a:t>of</a:t>
+            </a:r>
+            <a:r>
+              <a:rPr lang="hr-HR" dirty="0"/>
+              <a:t> </a:t>
+            </a:r>
+            <a:r>
+              <a:rPr lang="hr-HR" dirty="0" err="1"/>
+              <a:t>tools</a:t>
+            </a:r>
+            <a:r>
+              <a:rPr lang="hr-HR" dirty="0"/>
+              <a:t>, </a:t>
+            </a:r>
+            <a:r>
+              <a:rPr lang="hr-HR" dirty="0" err="1"/>
+              <a:t>skills</a:t>
+            </a:r>
+            <a:r>
+              <a:rPr lang="hr-HR" dirty="0"/>
+              <a:t> </a:t>
+            </a:r>
+            <a:r>
+              <a:rPr lang="hr-HR" dirty="0" err="1"/>
+              <a:t>and</a:t>
+            </a:r>
+            <a:r>
+              <a:rPr lang="hr-HR" dirty="0"/>
+              <a:t> </a:t>
+            </a:r>
+            <a:r>
+              <a:rPr lang="hr-HR" dirty="0" err="1"/>
+              <a:t>the</a:t>
+            </a:r>
+            <a:r>
+              <a:rPr lang="hr-HR" dirty="0"/>
+              <a:t> system </a:t>
+            </a:r>
+            <a:r>
+              <a:rPr lang="hr-HR" dirty="0" err="1"/>
+              <a:t>prompt</a:t>
+            </a:r>
+            <a:endParaRPr dirty="0"/>
+          </a:p>
+          <a:p>
+            <a:pPr lvl="0"/>
+            <a:r>
+              <a:rPr dirty="0"/>
+              <a:t>Keeps the </a:t>
+            </a:r>
+            <a:r>
+              <a:rPr b="1" dirty="0"/>
+              <a:t>default</a:t>
+            </a:r>
+            <a:r>
+              <a:rPr dirty="0"/>
+              <a:t> prompt small — important when PP costs 95 s</a:t>
+            </a:r>
+          </a:p>
+        </p:txBody>
+      </p:sp>
+    </p:spTree>
+  </p:cSld>
+  <p:clrMapOvr>
+    <a:masterClrMapping/>
+  </p:clrMapOvr>
+</p:sld>
+</file>
+
+<file path=ppt/slides/slide25.xml><?xml version="1.0" encoding="utf-8"?>
 <p:sld xmlns:a="http://schemas.openxmlformats.org/drawingml/2006/main" xmlns:r="http://schemas.openxmlformats.org/officeDocument/2006/relationships" xmlns:p="http://schemas.openxmlformats.org/presentationml/2006/main">
   <p:cSld>
     <p:spTree>
@@ -9075,348 +9328,6 @@
 </p:sld>
 </file>
 
-<file path=ppt/slides/slide25.xml><?xml version="1.0" encoding="utf-8"?>
-<p:sld xmlns:a="http://schemas.openxmlformats.org/drawingml/2006/main" xmlns:r="http://schemas.openxmlformats.org/officeDocument/2006/relationships" xmlns:p="http://schemas.openxmlformats.org/presentationml/2006/main">
-  <p:cSld>
-    <p:spTree>
-      <p:nvGrpSpPr>
-        <p:cNvPr id="1" name=""/>
-        <p:cNvGrpSpPr/>
-        <p:nvPr/>
-      </p:nvGrpSpPr>
-      <p:grpSpPr>
-        <a:xfrm>
-          <a:off x="0" y="0"/>
-          <a:ext cx="0" cy="0"/>
-          <a:chOff x="0" y="0"/>
-          <a:chExt cx="0" cy="0"/>
-        </a:xfrm>
-      </p:grpSpPr>
-      <p:sp>
-        <p:nvSpPr>
-          <p:cNvPr id="2" name="Title 1"/>
-          <p:cNvSpPr>
-            <a:spLocks noGrp="1"/>
-          </p:cNvSpPr>
-          <p:nvPr>
-            <p:ph type="title"/>
-          </p:nvPr>
-        </p:nvSpPr>
-        <p:spPr/>
-        <p:txBody>
-          <a:bodyPr/>
-          <a:lstStyle/>
-          <a:p>
-            <a:pPr marL="0" lvl="0" indent="0">
-              <a:buNone/>
-            </a:pPr>
-            <a:r>
-              <a:rPr dirty="0"/>
-              <a:t>No bash. </a:t>
-            </a:r>
-            <a:r>
-              <a:rPr lang="hr-HR" dirty="0"/>
-              <a:t>JavaScript</a:t>
-            </a:r>
-            <a:r>
-              <a:rPr dirty="0"/>
-              <a:t>!</a:t>
-            </a:r>
-          </a:p>
-        </p:txBody>
-      </p:sp>
-      <p:sp>
-        <p:nvSpPr>
-          <p:cNvPr id="3" name="Content Placeholder 2"/>
-          <p:cNvSpPr>
-            <a:spLocks noGrp="1"/>
-          </p:cNvSpPr>
-          <p:nvPr>
-            <p:ph sz="half" idx="1"/>
-          </p:nvPr>
-        </p:nvSpPr>
-        <p:spPr/>
-        <p:txBody>
-          <a:bodyPr>
-            <a:normAutofit fontScale="92500"/>
-          </a:bodyPr>
-          <a:lstStyle/>
-          <a:p>
-            <a:pPr marL="0" lvl="0" indent="0">
-              <a:spcBef>
-                <a:spcPts val="3000"/>
-              </a:spcBef>
-              <a:buNone/>
-            </a:pPr>
-            <a:r>
-              <a:rPr b="1" dirty="0"/>
-              <a:t>Pro: security</a:t>
-            </a:r>
-          </a:p>
-          <a:p>
-            <a:pPr lvl="0"/>
-            <a:r>
-              <a:rPr b="1" dirty="0"/>
-              <a:t>sandbox</a:t>
-            </a:r>
-            <a:r>
-              <a:rPr dirty="0"/>
-              <a:t>: no filesystem, no exec, no network except allow-listed </a:t>
-            </a:r>
-            <a:r>
-              <a:rPr dirty="0">
-                <a:latin typeface="Courier"/>
-              </a:rPr>
-              <a:t>fetch</a:t>
-            </a:r>
-          </a:p>
-          <a:p>
-            <a:pPr lvl="0"/>
-            <a:r>
-              <a:rPr b="1" dirty="0"/>
-              <a:t>Hard interrupt timeout</a:t>
-            </a:r>
-            <a:r>
-              <a:rPr dirty="0"/>
-              <a:t>, output caps</a:t>
-            </a:r>
-          </a:p>
-          <a:p>
-            <a:pPr lvl="0"/>
-            <a:r>
-              <a:rPr dirty="0"/>
-              <a:t>Per-user </a:t>
-            </a:r>
-            <a:r>
-              <a:rPr b="1" dirty="0"/>
-              <a:t>virtual stores </a:t>
-            </a:r>
-            <a:r>
-              <a:rPr dirty="0"/>
-              <a:t>(</a:t>
-            </a:r>
-            <a:r>
-              <a:rPr dirty="0">
-                <a:latin typeface="Courier"/>
-              </a:rPr>
-              <a:t>tmp://</a:t>
-            </a:r>
-            <a:r>
-              <a:rPr dirty="0"/>
-              <a:t>, </a:t>
-            </a:r>
-            <a:r>
-              <a:rPr dirty="0">
-                <a:latin typeface="Courier"/>
-              </a:rPr>
-              <a:t>storage://</a:t>
-            </a:r>
-            <a:r>
-              <a:rPr dirty="0"/>
-              <a:t>) instead of paths</a:t>
-            </a:r>
-          </a:p>
-          <a:p>
-            <a:pPr lvl="0"/>
-            <a:r>
-              <a:rPr dirty="0"/>
-              <a:t>Multi-user server: arbitrary shell </a:t>
-            </a:r>
-            <a:r>
-              <a:rPr lang="hr-HR" dirty="0" err="1"/>
-              <a:t>is</a:t>
-            </a:r>
-            <a:r>
-              <a:rPr dirty="0"/>
-              <a:t> never </a:t>
-            </a:r>
-            <a:r>
-              <a:rPr lang="hr-HR" dirty="0" err="1"/>
-              <a:t>the</a:t>
-            </a:r>
-            <a:r>
-              <a:rPr dirty="0"/>
-              <a:t> </a:t>
-            </a:r>
-            <a:r>
-              <a:rPr lang="hr-HR" dirty="0" err="1"/>
-              <a:t>first</a:t>
-            </a:r>
-            <a:r>
-              <a:rPr lang="hr-HR" dirty="0"/>
-              <a:t> </a:t>
-            </a:r>
-            <a:r>
-              <a:rPr lang="hr-HR" dirty="0" err="1"/>
-              <a:t>solution</a:t>
-            </a:r>
-            <a:endParaRPr lang="hr-HR" dirty="0"/>
-          </a:p>
-          <a:p>
-            <a:pPr lvl="0"/>
-            <a:r>
-              <a:rPr lang="hr-HR" dirty="0"/>
-              <a:t>(</a:t>
-            </a:r>
-            <a:r>
-              <a:rPr lang="hr-HR" dirty="0" err="1"/>
-              <a:t>will</a:t>
-            </a:r>
-            <a:r>
-              <a:rPr lang="hr-HR" dirty="0"/>
-              <a:t> </a:t>
-            </a:r>
-            <a:r>
-              <a:rPr lang="hr-HR" dirty="0" err="1"/>
-              <a:t>probably</a:t>
-            </a:r>
-            <a:r>
-              <a:rPr lang="hr-HR" dirty="0"/>
-              <a:t> </a:t>
-            </a:r>
-            <a:r>
-              <a:rPr lang="hr-HR" dirty="0" err="1"/>
-              <a:t>have</a:t>
-            </a:r>
-            <a:r>
-              <a:rPr lang="hr-HR" dirty="0"/>
-              <a:t> to use </a:t>
-            </a:r>
-            <a:r>
-              <a:rPr lang="hr-HR" dirty="0" err="1"/>
-              <a:t>it</a:t>
-            </a:r>
-            <a:r>
-              <a:rPr lang="hr-HR" dirty="0"/>
-              <a:t>…)</a:t>
-            </a:r>
-            <a:endParaRPr dirty="0"/>
-          </a:p>
-        </p:txBody>
-      </p:sp>
-      <p:sp>
-        <p:nvSpPr>
-          <p:cNvPr id="4" name="Content Placeholder 3"/>
-          <p:cNvSpPr>
-            <a:spLocks noGrp="1"/>
-          </p:cNvSpPr>
-          <p:nvPr>
-            <p:ph sz="half" idx="2"/>
-          </p:nvPr>
-        </p:nvSpPr>
-        <p:spPr/>
-        <p:txBody>
-          <a:bodyPr>
-            <a:normAutofit fontScale="92500"/>
-          </a:bodyPr>
-          <a:lstStyle/>
-          <a:p>
-            <a:pPr marL="0" lvl="0" indent="0">
-              <a:spcBef>
-                <a:spcPts val="3000"/>
-              </a:spcBef>
-              <a:buNone/>
-            </a:pPr>
-            <a:r>
-              <a:rPr b="1" dirty="0"/>
-              <a:t>Con: flexibility</a:t>
-            </a:r>
-          </a:p>
-          <a:p>
-            <a:pPr lvl="0"/>
-            <a:r>
-              <a:rPr dirty="0"/>
-              <a:t>ES5.1 + much of ES6 (</a:t>
-            </a:r>
-            <a:r>
-              <a:rPr lang="hr-HR" dirty="0" err="1"/>
-              <a:t>built-in</a:t>
-            </a:r>
-            <a:r>
-              <a:rPr lang="hr-HR" dirty="0"/>
-              <a:t> </a:t>
-            </a:r>
-            <a:r>
-              <a:rPr lang="hr-HR" dirty="0" err="1"/>
-              <a:t>interpreter</a:t>
-            </a:r>
-            <a:r>
-              <a:rPr lang="hr-HR" dirty="0"/>
-              <a:t> </a:t>
-            </a:r>
-            <a:r>
-              <a:rPr lang="hr-HR" dirty="0" err="1"/>
-              <a:t>named</a:t>
-            </a:r>
-            <a:r>
-              <a:rPr lang="hr-HR" dirty="0"/>
-              <a:t> „</a:t>
-            </a:r>
-            <a:r>
-              <a:rPr lang="hr-HR" dirty="0" err="1"/>
-              <a:t>goja</a:t>
-            </a:r>
-            <a:r>
-              <a:rPr lang="hr-HR" dirty="0"/>
-              <a:t>”</a:t>
-            </a:r>
-            <a:r>
-              <a:rPr dirty="0"/>
-              <a:t>) — no </a:t>
-            </a:r>
-            <a:r>
-              <a:rPr dirty="0" err="1"/>
-              <a:t>npm</a:t>
-            </a:r>
-            <a:r>
-              <a:rPr dirty="0"/>
-              <a:t>, no node APIs</a:t>
-            </a:r>
-          </a:p>
-          <a:p>
-            <a:pPr lvl="0"/>
-            <a:r>
-              <a:rPr dirty="0"/>
-              <a:t>No external tools or pipes; everything via injected helpers (</a:t>
-            </a:r>
-            <a:r>
-              <a:rPr dirty="0">
-                <a:latin typeface="Courier"/>
-              </a:rPr>
-              <a:t>dom.*</a:t>
-            </a:r>
-            <a:r>
-              <a:rPr dirty="0"/>
-              <a:t>, </a:t>
-            </a:r>
-            <a:r>
-              <a:rPr dirty="0">
-                <a:latin typeface="Courier"/>
-              </a:rPr>
-              <a:t>fetch</a:t>
-            </a:r>
-            <a:r>
-              <a:rPr dirty="0"/>
-              <a:t>)</a:t>
-            </a:r>
-          </a:p>
-          <a:p>
-            <a:pPr lvl="0"/>
-            <a:r>
-              <a:rPr dirty="0"/>
-              <a:t>Long-tail tasks need a helper added server-side first</a:t>
-            </a:r>
-          </a:p>
-        </p:txBody>
-      </p:sp>
-    </p:spTree>
-  </p:cSld>
-  <p:clrMapOvr>
-    <a:masterClrMapping/>
-  </p:clrMapOvr>
-</p:sld>
-</file>
-
 <file path=ppt/slides/slide26.xml><?xml version="1.0" encoding="utf-8"?>
 <p:sld xmlns:a="http://schemas.openxmlformats.org/drawingml/2006/main" xmlns:r="http://schemas.openxmlformats.org/officeDocument/2006/relationships" xmlns:p="http://schemas.openxmlformats.org/presentationml/2006/main">
   <p:cSld>
@@ -9436,12 +9347,12 @@
       </p:grpSpPr>
       <p:sp>
         <p:nvSpPr>
-          <p:cNvPr id="3" name="Content Placeholder 2"/>
+          <p:cNvPr id="2" name="Title 1"/>
           <p:cNvSpPr>
             <a:spLocks noGrp="1"/>
           </p:cNvSpPr>
           <p:nvPr>
-            <p:ph idx="1"/>
+            <p:ph type="title"/>
           </p:nvPr>
         </p:nvSpPr>
         <p:spPr/>
@@ -9453,16 +9364,300 @@
               <a:buNone/>
             </a:pPr>
             <a:r>
-              <a:t>Same sandbox everywhere: </a:t>
-            </a:r>
-            <a:r>
-              <a:rPr>
+              <a:rPr dirty="0"/>
+              <a:t>No bash. </a:t>
+            </a:r>
+            <a:r>
+              <a:rPr lang="hr-HR" dirty="0"/>
+              <a:t>JavaScript</a:t>
+            </a:r>
+            <a:r>
+              <a:rPr dirty="0"/>
+              <a:t>!</a:t>
+            </a:r>
+          </a:p>
+        </p:txBody>
+      </p:sp>
+      <p:sp>
+        <p:nvSpPr>
+          <p:cNvPr id="3" name="Content Placeholder 2"/>
+          <p:cNvSpPr>
+            <a:spLocks noGrp="1"/>
+          </p:cNvSpPr>
+          <p:nvPr>
+            <p:ph sz="half" idx="1"/>
+          </p:nvPr>
+        </p:nvSpPr>
+        <p:spPr/>
+        <p:txBody>
+          <a:bodyPr>
+            <a:normAutofit fontScale="92500"/>
+          </a:bodyPr>
+          <a:lstStyle/>
+          <a:p>
+            <a:pPr marL="0" lvl="0" indent="0">
+              <a:spcBef>
+                <a:spcPts val="3000"/>
+              </a:spcBef>
+              <a:buNone/>
+            </a:pPr>
+            <a:r>
+              <a:rPr b="1" dirty="0"/>
+              <a:t>Pro: security</a:t>
+            </a:r>
+          </a:p>
+          <a:p>
+            <a:pPr lvl="0"/>
+            <a:r>
+              <a:rPr b="1" dirty="0"/>
+              <a:t>sandbox</a:t>
+            </a:r>
+            <a:r>
+              <a:rPr dirty="0"/>
+              <a:t>: no filesystem, no exec, no network except allow-listed </a:t>
+            </a:r>
+            <a:r>
+              <a:rPr dirty="0">
                 <a:latin typeface="Courier"/>
               </a:rPr>
-              <a:t>run_js</a:t>
-            </a:r>
-            <a:r>
-              <a:t> tool · skill templating · skill-defined tools · cron jobs</a:t>
+              <a:t>fetch</a:t>
+            </a:r>
+          </a:p>
+          <a:p>
+            <a:pPr lvl="0"/>
+            <a:r>
+              <a:rPr b="1" dirty="0"/>
+              <a:t>Hard interrupt timeout</a:t>
+            </a:r>
+            <a:r>
+              <a:rPr dirty="0"/>
+              <a:t>, output caps</a:t>
+            </a:r>
+          </a:p>
+          <a:p>
+            <a:pPr lvl="0"/>
+            <a:r>
+              <a:rPr dirty="0"/>
+              <a:t>Per-user </a:t>
+            </a:r>
+            <a:r>
+              <a:rPr b="1" dirty="0"/>
+              <a:t>virtual stores </a:t>
+            </a:r>
+            <a:r>
+              <a:rPr dirty="0"/>
+              <a:t>(</a:t>
+            </a:r>
+            <a:r>
+              <a:rPr dirty="0">
+                <a:latin typeface="Courier"/>
+              </a:rPr>
+              <a:t>tmp://</a:t>
+            </a:r>
+            <a:r>
+              <a:rPr dirty="0"/>
+              <a:t>, </a:t>
+            </a:r>
+            <a:r>
+              <a:rPr dirty="0">
+                <a:latin typeface="Courier"/>
+              </a:rPr>
+              <a:t>storage://</a:t>
+            </a:r>
+            <a:r>
+              <a:rPr dirty="0"/>
+              <a:t>) instead of paths</a:t>
+            </a:r>
+          </a:p>
+          <a:p>
+            <a:pPr lvl="0"/>
+            <a:r>
+              <a:rPr dirty="0"/>
+              <a:t>Multi-user server: arbitrary shell </a:t>
+            </a:r>
+            <a:r>
+              <a:rPr lang="hr-HR" dirty="0" err="1"/>
+              <a:t>is</a:t>
+            </a:r>
+            <a:r>
+              <a:rPr dirty="0"/>
+              <a:t> never </a:t>
+            </a:r>
+            <a:r>
+              <a:rPr lang="hr-HR" dirty="0" err="1"/>
+              <a:t>the</a:t>
+            </a:r>
+            <a:r>
+              <a:rPr dirty="0"/>
+              <a:t> </a:t>
+            </a:r>
+            <a:r>
+              <a:rPr lang="hr-HR" dirty="0" err="1"/>
+              <a:t>first</a:t>
+            </a:r>
+            <a:r>
+              <a:rPr lang="hr-HR" dirty="0"/>
+              <a:t> </a:t>
+            </a:r>
+            <a:r>
+              <a:rPr lang="hr-HR" dirty="0" err="1"/>
+              <a:t>solution</a:t>
+            </a:r>
+            <a:endParaRPr lang="hr-HR" dirty="0"/>
+          </a:p>
+          <a:p>
+            <a:pPr lvl="0"/>
+            <a:r>
+              <a:rPr lang="hr-HR" dirty="0"/>
+              <a:t>(</a:t>
+            </a:r>
+            <a:r>
+              <a:rPr lang="hr-HR" dirty="0" err="1"/>
+              <a:t>will</a:t>
+            </a:r>
+            <a:r>
+              <a:rPr lang="hr-HR" dirty="0"/>
+              <a:t> </a:t>
+            </a:r>
+            <a:r>
+              <a:rPr lang="hr-HR" dirty="0" err="1"/>
+              <a:t>probably</a:t>
+            </a:r>
+            <a:r>
+              <a:rPr lang="hr-HR" dirty="0"/>
+              <a:t> </a:t>
+            </a:r>
+            <a:r>
+              <a:rPr lang="hr-HR" dirty="0" err="1"/>
+              <a:t>have</a:t>
+            </a:r>
+            <a:r>
+              <a:rPr lang="hr-HR" dirty="0"/>
+              <a:t> to use </a:t>
+            </a:r>
+            <a:r>
+              <a:rPr lang="hr-HR" dirty="0" err="1"/>
+              <a:t>it</a:t>
+            </a:r>
+            <a:r>
+              <a:rPr lang="hr-HR" dirty="0"/>
+              <a:t>…)</a:t>
+            </a:r>
+            <a:endParaRPr dirty="0"/>
+          </a:p>
+        </p:txBody>
+      </p:sp>
+      <p:sp>
+        <p:nvSpPr>
+          <p:cNvPr id="4" name="Content Placeholder 3"/>
+          <p:cNvSpPr>
+            <a:spLocks noGrp="1"/>
+          </p:cNvSpPr>
+          <p:nvPr>
+            <p:ph sz="half" idx="2"/>
+          </p:nvPr>
+        </p:nvSpPr>
+        <p:spPr/>
+        <p:txBody>
+          <a:bodyPr>
+            <a:normAutofit fontScale="92500"/>
+          </a:bodyPr>
+          <a:lstStyle/>
+          <a:p>
+            <a:pPr marL="0" lvl="0" indent="0">
+              <a:spcBef>
+                <a:spcPts val="3000"/>
+              </a:spcBef>
+              <a:buNone/>
+            </a:pPr>
+            <a:r>
+              <a:rPr b="1" dirty="0"/>
+              <a:t>Con: flexibility</a:t>
+            </a:r>
+          </a:p>
+          <a:p>
+            <a:pPr lvl="0"/>
+            <a:r>
+              <a:rPr dirty="0"/>
+              <a:t>ES5.1 + much of ES6 (</a:t>
+            </a:r>
+            <a:r>
+              <a:rPr lang="hr-HR" dirty="0" err="1"/>
+              <a:t>built-in</a:t>
+            </a:r>
+            <a:r>
+              <a:rPr lang="hr-HR" dirty="0"/>
+              <a:t> </a:t>
+            </a:r>
+            <a:r>
+              <a:rPr lang="hr-HR" dirty="0" err="1"/>
+              <a:t>interpreter</a:t>
+            </a:r>
+            <a:r>
+              <a:rPr lang="hr-HR" dirty="0"/>
+              <a:t> </a:t>
+            </a:r>
+            <a:r>
+              <a:rPr lang="hr-HR" dirty="0" err="1"/>
+              <a:t>named</a:t>
+            </a:r>
+            <a:r>
+              <a:rPr lang="hr-HR" dirty="0"/>
+              <a:t> „</a:t>
+            </a:r>
+            <a:r>
+              <a:rPr lang="hr-HR" dirty="0" err="1"/>
+              <a:t>goja</a:t>
+            </a:r>
+            <a:r>
+              <a:rPr lang="hr-HR" dirty="0"/>
+              <a:t>”</a:t>
+            </a:r>
+            <a:r>
+              <a:rPr dirty="0"/>
+              <a:t>) — no </a:t>
+            </a:r>
+            <a:r>
+              <a:rPr dirty="0" err="1"/>
+              <a:t>npm</a:t>
+            </a:r>
+            <a:r>
+              <a:rPr dirty="0"/>
+              <a:t>, no node APIs</a:t>
+            </a:r>
+          </a:p>
+          <a:p>
+            <a:pPr lvl="0"/>
+            <a:r>
+              <a:rPr dirty="0"/>
+              <a:t>No external tools or pipes; everything via injected helpers (</a:t>
+            </a:r>
+            <a:r>
+              <a:rPr dirty="0">
+                <a:latin typeface="Courier"/>
+              </a:rPr>
+              <a:t>dom.*</a:t>
+            </a:r>
+            <a:r>
+              <a:rPr dirty="0"/>
+              <a:t>, </a:t>
+            </a:r>
+            <a:r>
+              <a:rPr dirty="0">
+                <a:latin typeface="Courier"/>
+              </a:rPr>
+              <a:t>fetch</a:t>
+            </a:r>
+            <a:r>
+              <a:rPr dirty="0"/>
+              <a:t>)</a:t>
+            </a:r>
+          </a:p>
+          <a:p>
+            <a:pPr lvl="0"/>
+            <a:r>
+              <a:rPr dirty="0"/>
+              <a:t>Long-tail tasks need a helper added server-side first</a:t>
             </a:r>
           </a:p>
         </p:txBody>
@@ -9494,12 +9689,12 @@
       </p:grpSpPr>
       <p:sp>
         <p:nvSpPr>
-          <p:cNvPr id="2" name="Title 1"/>
+          <p:cNvPr id="3" name="Content Placeholder 2"/>
           <p:cNvSpPr>
             <a:spLocks noGrp="1"/>
           </p:cNvSpPr>
           <p:nvPr>
-            <p:ph type="title"/>
+            <p:ph idx="1"/>
           </p:nvPr>
         </p:nvSpPr>
         <p:spPr/>
@@ -9511,116 +9706,16 @@
               <a:buNone/>
             </a:pPr>
             <a:r>
-              <a:t>Making a 26B model behave</a:t>
-            </a:r>
-          </a:p>
-        </p:txBody>
-      </p:sp>
-      <p:sp>
-        <p:nvSpPr>
-          <p:cNvPr id="3" name="Content Placeholder 2"/>
-          <p:cNvSpPr>
-            <a:spLocks noGrp="1"/>
-          </p:cNvSpPr>
-          <p:nvPr>
-            <p:ph idx="1"/>
-          </p:nvPr>
-        </p:nvSpPr>
-        <p:spPr/>
-        <p:txBody>
-          <a:bodyPr>
-            <a:normAutofit fontScale="85000" lnSpcReduction="10000"/>
-          </a:bodyPr>
-          <a:lstStyle/>
-          <a:p>
-            <a:pPr lvl="0"/>
-            <a:r>
-              <a:rPr dirty="0"/>
-              <a:t>System prompt engineering for small models: short sections, one rule per bullet, </a:t>
-            </a:r>
-            <a:r>
-              <a:rPr b="1" dirty="0"/>
-              <a:t>examples over abstractions</a:t>
-            </a:r>
-            <a:r>
-              <a:rPr dirty="0"/>
-              <a:t>, mechanical decision rules</a:t>
-            </a:r>
-          </a:p>
-          <a:p>
-            <a:pPr lvl="0"/>
-            <a:r>
-              <a:rPr dirty="0"/>
-              <a:t>“Computed answers”: single expression → calculator; multi-step → </a:t>
-            </a:r>
-            <a:r>
-              <a:rPr dirty="0" err="1">
+              <a:t>Same sandbox everywhere: </a:t>
+            </a:r>
+            <a:r>
+              <a:rPr>
                 <a:latin typeface="Courier"/>
               </a:rPr>
               <a:t>run_js</a:t>
             </a:r>
             <a:r>
-              <a:rPr dirty="0"/>
-              <a:t>; the answer must repeat tool output </a:t>
-            </a:r>
-            <a:r>
-              <a:rPr b="1" dirty="0"/>
-              <a:t>exactly</a:t>
-            </a:r>
-          </a:p>
-          <a:p>
-            <a:pPr lvl="0"/>
-            <a:r>
-              <a:rPr dirty="0"/>
-              <a:t>Judges: structured JSON + confidence gate (≥ 7) for every unattended decision</a:t>
-            </a:r>
-          </a:p>
-          <a:p>
-            <a:pPr lvl="0"/>
-            <a:r>
-              <a:rPr dirty="0"/>
-              <a:t>Grounding: tool output is </a:t>
-            </a:r>
-            <a:r>
-              <a:rPr b="1" dirty="0"/>
-              <a:t>data, not instructions</a:t>
-            </a:r>
-            <a:r>
-              <a:rPr dirty="0"/>
-              <a:t> (web content!); “don’t know” beats guessing</a:t>
-            </a:r>
-          </a:p>
-          <a:p>
-            <a:pPr marL="1270000" lvl="0" indent="0">
-              <a:buNone/>
-            </a:pPr>
-            <a:r>
-              <a:rPr sz="2000" dirty="0"/>
-              <a:t>Same 26B model, same question (“first 200 digits of π”): </a:t>
-            </a:r>
-            <a:r>
-              <a:rPr sz="2000" b="1" dirty="0"/>
-              <a:t>before</a:t>
-            </a:r>
-            <a:r>
-              <a:rPr sz="2000" dirty="0"/>
-              <a:t> — recites digits from its weights, ignores its own buggy script; </a:t>
-            </a:r>
-            <a:r>
-              <a:rPr sz="2000" b="1" dirty="0"/>
-              <a:t>after</a:t>
-            </a:r>
-            <a:r>
-              <a:rPr sz="2000" dirty="0"/>
-              <a:t> — writes a </a:t>
-            </a:r>
-            <a:r>
-              <a:rPr sz="2000" dirty="0" err="1"/>
-              <a:t>BigInt</a:t>
-            </a:r>
-            <a:r>
-              <a:rPr sz="2000" dirty="0"/>
-              <a:t> Machin series, self-corrects, answers from tool output.</a:t>
+              <a:t> tool · skill templating · skill-defined tools · cron jobs</a:t>
             </a:r>
           </a:p>
         </p:txBody>
@@ -9634,6 +9729,164 @@
 </file>
 
 <file path=ppt/slides/slide28.xml><?xml version="1.0" encoding="utf-8"?>
+<p:sld xmlns:a="http://schemas.openxmlformats.org/drawingml/2006/main" xmlns:r="http://schemas.openxmlformats.org/officeDocument/2006/relationships" xmlns:p="http://schemas.openxmlformats.org/presentationml/2006/main">
+  <p:cSld>
+    <p:spTree>
+      <p:nvGrpSpPr>
+        <p:cNvPr id="1" name=""/>
+        <p:cNvGrpSpPr/>
+        <p:nvPr/>
+      </p:nvGrpSpPr>
+      <p:grpSpPr>
+        <a:xfrm>
+          <a:off x="0" y="0"/>
+          <a:ext cx="0" cy="0"/>
+          <a:chOff x="0" y="0"/>
+          <a:chExt cx="0" cy="0"/>
+        </a:xfrm>
+      </p:grpSpPr>
+      <p:sp>
+        <p:nvSpPr>
+          <p:cNvPr id="2" name="Title 1"/>
+          <p:cNvSpPr>
+            <a:spLocks noGrp="1"/>
+          </p:cNvSpPr>
+          <p:nvPr>
+            <p:ph type="title"/>
+          </p:nvPr>
+        </p:nvSpPr>
+        <p:spPr/>
+        <p:txBody>
+          <a:bodyPr/>
+          <a:lstStyle/>
+          <a:p>
+            <a:pPr marL="0" lvl="0" indent="0">
+              <a:buNone/>
+            </a:pPr>
+            <a:r>
+              <a:t>Making a 26B model behave</a:t>
+            </a:r>
+          </a:p>
+        </p:txBody>
+      </p:sp>
+      <p:sp>
+        <p:nvSpPr>
+          <p:cNvPr id="3" name="Content Placeholder 2"/>
+          <p:cNvSpPr>
+            <a:spLocks noGrp="1"/>
+          </p:cNvSpPr>
+          <p:nvPr>
+            <p:ph idx="1"/>
+          </p:nvPr>
+        </p:nvSpPr>
+        <p:spPr/>
+        <p:txBody>
+          <a:bodyPr>
+            <a:normAutofit fontScale="85000" lnSpcReduction="10000"/>
+          </a:bodyPr>
+          <a:lstStyle/>
+          <a:p>
+            <a:pPr lvl="0"/>
+            <a:r>
+              <a:rPr dirty="0"/>
+              <a:t>System prompt engineering for small models: short sections, one rule per bullet, </a:t>
+            </a:r>
+            <a:r>
+              <a:rPr b="1" dirty="0"/>
+              <a:t>examples over abstractions</a:t>
+            </a:r>
+            <a:r>
+              <a:rPr dirty="0"/>
+              <a:t>, mechanical decision rules</a:t>
+            </a:r>
+          </a:p>
+          <a:p>
+            <a:pPr lvl="0"/>
+            <a:r>
+              <a:rPr dirty="0"/>
+              <a:t>“Computed answers”: single expression → calculator; multi-step → </a:t>
+            </a:r>
+            <a:r>
+              <a:rPr dirty="0" err="1">
+                <a:latin typeface="Courier"/>
+              </a:rPr>
+              <a:t>run_js</a:t>
+            </a:r>
+            <a:r>
+              <a:rPr dirty="0"/>
+              <a:t>; the answer must repeat tool output </a:t>
+            </a:r>
+            <a:r>
+              <a:rPr b="1" dirty="0"/>
+              <a:t>exactly</a:t>
+            </a:r>
+          </a:p>
+          <a:p>
+            <a:pPr lvl="0"/>
+            <a:r>
+              <a:rPr dirty="0"/>
+              <a:t>Judges: structured JSON + confidence gate (≥ 7) for every unattended decision</a:t>
+            </a:r>
+          </a:p>
+          <a:p>
+            <a:pPr lvl="0"/>
+            <a:r>
+              <a:rPr dirty="0"/>
+              <a:t>Grounding: tool output is </a:t>
+            </a:r>
+            <a:r>
+              <a:rPr b="1" dirty="0"/>
+              <a:t>data, not instructions</a:t>
+            </a:r>
+            <a:r>
+              <a:rPr dirty="0"/>
+              <a:t> (web content!); “don’t know” beats guessing</a:t>
+            </a:r>
+          </a:p>
+          <a:p>
+            <a:pPr marL="1270000" lvl="0" indent="0">
+              <a:buNone/>
+            </a:pPr>
+            <a:r>
+              <a:rPr sz="2000" dirty="0"/>
+              <a:t>Same 26B model, same question (“first 200 digits of π”): </a:t>
+            </a:r>
+            <a:r>
+              <a:rPr sz="2000" b="1" dirty="0"/>
+              <a:t>before</a:t>
+            </a:r>
+            <a:r>
+              <a:rPr sz="2000" dirty="0"/>
+              <a:t> — recites digits from its weights, ignores its own buggy script; </a:t>
+            </a:r>
+            <a:r>
+              <a:rPr sz="2000" b="1" dirty="0"/>
+              <a:t>after</a:t>
+            </a:r>
+            <a:r>
+              <a:rPr sz="2000" dirty="0"/>
+              <a:t> — writes a </a:t>
+            </a:r>
+            <a:r>
+              <a:rPr sz="2000" dirty="0" err="1"/>
+              <a:t>BigInt</a:t>
+            </a:r>
+            <a:r>
+              <a:rPr sz="2000" dirty="0"/>
+              <a:t> Machin series, self-corrects, answers from tool output.</a:t>
+            </a:r>
+          </a:p>
+        </p:txBody>
+      </p:sp>
+    </p:spTree>
+  </p:cSld>
+  <p:clrMapOvr>
+    <a:masterClrMapping/>
+  </p:clrMapOvr>
+</p:sld>
+</file>
+
+<file path=ppt/slides/slide29.xml><?xml version="1.0" encoding="utf-8"?>
 <p:sld xmlns:a="http://schemas.openxmlformats.org/drawingml/2006/main" xmlns:r="http://schemas.openxmlformats.org/officeDocument/2006/relationships" xmlns:p="http://schemas.openxmlformats.org/presentationml/2006/main">
   <p:cSld>
     <p:spTree>
@@ -10001,7 +10254,178 @@
 </p:sld>
 </file>
 
-<file path=ppt/slides/slide29.xml><?xml version="1.0" encoding="utf-8"?>
+<file path=ppt/slides/slide3.xml><?xml version="1.0" encoding="utf-8"?>
+<p:sld xmlns:a="http://schemas.openxmlformats.org/drawingml/2006/main" xmlns:r="http://schemas.openxmlformats.org/officeDocument/2006/relationships" xmlns:p="http://schemas.openxmlformats.org/presentationml/2006/main">
+  <p:cSld>
+    <p:spTree>
+      <p:nvGrpSpPr>
+        <p:cNvPr id="1" name=""/>
+        <p:cNvGrpSpPr/>
+        <p:nvPr/>
+      </p:nvGrpSpPr>
+      <p:grpSpPr>
+        <a:xfrm>
+          <a:off x="0" y="0"/>
+          <a:ext cx="0" cy="0"/>
+          <a:chOff x="0" y="0"/>
+          <a:chExt cx="0" cy="0"/>
+        </a:xfrm>
+      </p:grpSpPr>
+      <p:sp>
+        <p:nvSpPr>
+          <p:cNvPr id="2" name="Title 1">
+            <a:extLst>
+              <a:ext uri="{FF2B5EF4-FFF2-40B4-BE49-F238E27FC236}">
+                <a16:creationId xmlns:a16="http://schemas.microsoft.com/office/drawing/2014/main" id="{7F3B32D2-7D99-4224-5E25-AD1A0493F04D}"/>
+              </a:ext>
+            </a:extLst>
+          </p:cNvPr>
+          <p:cNvSpPr>
+            <a:spLocks noGrp="1"/>
+          </p:cNvSpPr>
+          <p:nvPr>
+            <p:ph type="title"/>
+          </p:nvPr>
+        </p:nvSpPr>
+        <p:spPr/>
+        <p:txBody>
+          <a:bodyPr/>
+          <a:lstStyle/>
+          <a:p>
+            <a:r>
+              <a:rPr lang="en-US" noProof="0" dirty="0"/>
+              <a:t>What?</a:t>
+            </a:r>
+          </a:p>
+        </p:txBody>
+      </p:sp>
+      <p:sp>
+        <p:nvSpPr>
+          <p:cNvPr id="3" name="Content Placeholder 2">
+            <a:extLst>
+              <a:ext uri="{FF2B5EF4-FFF2-40B4-BE49-F238E27FC236}">
+                <a16:creationId xmlns:a16="http://schemas.microsoft.com/office/drawing/2014/main" id="{E848E1B5-719C-8BC3-EB6E-E79A12F30334}"/>
+              </a:ext>
+            </a:extLst>
+          </p:cNvPr>
+          <p:cNvSpPr>
+            <a:spLocks noGrp="1"/>
+          </p:cNvSpPr>
+          <p:nvPr>
+            <p:ph idx="1"/>
+          </p:nvPr>
+        </p:nvSpPr>
+        <p:spPr/>
+        <p:txBody>
+          <a:bodyPr>
+            <a:normAutofit/>
+          </a:bodyPr>
+          <a:lstStyle/>
+          <a:p>
+            <a:pPr lvl="0"/>
+            <a:r>
+              <a:rPr lang="en-US" noProof="0" dirty="0"/>
+              <a:t>Harlequin: a </a:t>
+            </a:r>
+            <a:r>
+              <a:rPr lang="en-US" b="1" noProof="0" dirty="0"/>
+              <a:t>client-server</a:t>
+            </a:r>
+            <a:r>
+              <a:rPr lang="en-US" noProof="0" dirty="0"/>
+              <a:t> AI agent harness</a:t>
+            </a:r>
+          </a:p>
+          <a:p>
+            <a:pPr lvl="1"/>
+            <a:r>
+              <a:rPr lang="en-US" noProof="0" dirty="0"/>
+              <a:t>REST/SSE server</a:t>
+            </a:r>
+          </a:p>
+          <a:p>
+            <a:pPr lvl="1"/>
+            <a:r>
+              <a:rPr lang="hr-HR" noProof="0" dirty="0"/>
+              <a:t>T</a:t>
+            </a:r>
+            <a:r>
+              <a:rPr lang="en-US" noProof="0" dirty="0" err="1"/>
+              <a:t>hin</a:t>
+            </a:r>
+            <a:r>
+              <a:rPr lang="en-US" noProof="0" dirty="0"/>
+              <a:t> clients</a:t>
+            </a:r>
+          </a:p>
+          <a:p>
+            <a:pPr lvl="1"/>
+            <a:r>
+              <a:rPr lang="hr-HR" noProof="0" dirty="0"/>
+              <a:t>O</a:t>
+            </a:r>
+            <a:r>
+              <a:rPr lang="en-US" noProof="0" dirty="0" err="1"/>
+              <a:t>ptimized</a:t>
+            </a:r>
+            <a:r>
+              <a:rPr lang="en-US" noProof="0" dirty="0"/>
+              <a:t> for a </a:t>
+            </a:r>
+            <a:r>
+              <a:rPr lang="en-US" b="1" noProof="0" dirty="0"/>
+              <a:t>local model</a:t>
+            </a:r>
+            <a:r>
+              <a:rPr lang="en-US" noProof="0" dirty="0"/>
+              <a:t>: one GPU, slow tokens, every token paid in latency</a:t>
+            </a:r>
+          </a:p>
+          <a:p>
+            <a:pPr lvl="0"/>
+            <a:r>
+              <a:rPr lang="en-US" noProof="0" dirty="0"/>
+              <a:t>Research project · Go · SQLite · </a:t>
+            </a:r>
+            <a:r>
+              <a:rPr lang="en-US" noProof="0" dirty="0" err="1"/>
+              <a:t>goja</a:t>
+            </a:r>
+            <a:r>
+              <a:rPr lang="en-US" noProof="0" dirty="0"/>
+              <a:t> JS sandbox</a:t>
+            </a:r>
+          </a:p>
+          <a:p>
+            <a:pPr lvl="1"/>
+            <a:r>
+              <a:rPr lang="en-US" noProof="0" dirty="0"/>
+              <a:t>Lightweight, no bells-and-whistles</a:t>
+            </a:r>
+          </a:p>
+          <a:p>
+            <a:pPr lvl="1"/>
+            <a:r>
+              <a:rPr lang="en-US" noProof="0" dirty="0"/>
+              <a:t>Dubiously useful</a:t>
+            </a:r>
+          </a:p>
+        </p:txBody>
+      </p:sp>
+    </p:spTree>
+    <p:extLst>
+      <p:ext uri="{BB962C8B-B14F-4D97-AF65-F5344CB8AC3E}">
+        <p14:creationId xmlns:p14="http://schemas.microsoft.com/office/powerpoint/2010/main" val="4250528982"/>
+      </p:ext>
+    </p:extLst>
+  </p:cSld>
+  <p:clrMapOvr>
+    <a:masterClrMapping/>
+  </p:clrMapOvr>
+</p:sld>
+</file>
+
+<file path=ppt/slides/slide30.xml><?xml version="1.0" encoding="utf-8"?>
 <p:sld xmlns:a="http://schemas.openxmlformats.org/drawingml/2006/main" xmlns:r="http://schemas.openxmlformats.org/officeDocument/2006/relationships" xmlns:p="http://schemas.openxmlformats.org/presentationml/2006/main">
   <p:cSld>
     <p:spTree>
@@ -10200,177 +10624,6 @@
         </p:txBody>
       </p:sp>
     </p:spTree>
-  </p:cSld>
-  <p:clrMapOvr>
-    <a:masterClrMapping/>
-  </p:clrMapOvr>
-</p:sld>
-</file>
-
-<file path=ppt/slides/slide3.xml><?xml version="1.0" encoding="utf-8"?>
-<p:sld xmlns:a="http://schemas.openxmlformats.org/drawingml/2006/main" xmlns:r="http://schemas.openxmlformats.org/officeDocument/2006/relationships" xmlns:p="http://schemas.openxmlformats.org/presentationml/2006/main">
-  <p:cSld>
-    <p:spTree>
-      <p:nvGrpSpPr>
-        <p:cNvPr id="1" name=""/>
-        <p:cNvGrpSpPr/>
-        <p:nvPr/>
-      </p:nvGrpSpPr>
-      <p:grpSpPr>
-        <a:xfrm>
-          <a:off x="0" y="0"/>
-          <a:ext cx="0" cy="0"/>
-          <a:chOff x="0" y="0"/>
-          <a:chExt cx="0" cy="0"/>
-        </a:xfrm>
-      </p:grpSpPr>
-      <p:sp>
-        <p:nvSpPr>
-          <p:cNvPr id="2" name="Title 1">
-            <a:extLst>
-              <a:ext uri="{FF2B5EF4-FFF2-40B4-BE49-F238E27FC236}">
-                <a16:creationId xmlns:a16="http://schemas.microsoft.com/office/drawing/2014/main" id="{7F3B32D2-7D99-4224-5E25-AD1A0493F04D}"/>
-              </a:ext>
-            </a:extLst>
-          </p:cNvPr>
-          <p:cNvSpPr>
-            <a:spLocks noGrp="1"/>
-          </p:cNvSpPr>
-          <p:nvPr>
-            <p:ph type="title"/>
-          </p:nvPr>
-        </p:nvSpPr>
-        <p:spPr/>
-        <p:txBody>
-          <a:bodyPr/>
-          <a:lstStyle/>
-          <a:p>
-            <a:r>
-              <a:rPr lang="en-US" noProof="0" dirty="0"/>
-              <a:t>What?</a:t>
-            </a:r>
-          </a:p>
-        </p:txBody>
-      </p:sp>
-      <p:sp>
-        <p:nvSpPr>
-          <p:cNvPr id="3" name="Content Placeholder 2">
-            <a:extLst>
-              <a:ext uri="{FF2B5EF4-FFF2-40B4-BE49-F238E27FC236}">
-                <a16:creationId xmlns:a16="http://schemas.microsoft.com/office/drawing/2014/main" id="{E848E1B5-719C-8BC3-EB6E-E79A12F30334}"/>
-              </a:ext>
-            </a:extLst>
-          </p:cNvPr>
-          <p:cNvSpPr>
-            <a:spLocks noGrp="1"/>
-          </p:cNvSpPr>
-          <p:nvPr>
-            <p:ph idx="1"/>
-          </p:nvPr>
-        </p:nvSpPr>
-        <p:spPr/>
-        <p:txBody>
-          <a:bodyPr>
-            <a:normAutofit/>
-          </a:bodyPr>
-          <a:lstStyle/>
-          <a:p>
-            <a:pPr lvl="0"/>
-            <a:r>
-              <a:rPr lang="en-US" noProof="0" dirty="0"/>
-              <a:t>Harlequin: a </a:t>
-            </a:r>
-            <a:r>
-              <a:rPr lang="en-US" b="1" noProof="0" dirty="0"/>
-              <a:t>client-server</a:t>
-            </a:r>
-            <a:r>
-              <a:rPr lang="en-US" noProof="0" dirty="0"/>
-              <a:t> AI agent harness</a:t>
-            </a:r>
-          </a:p>
-          <a:p>
-            <a:pPr lvl="1"/>
-            <a:r>
-              <a:rPr lang="en-US" noProof="0" dirty="0"/>
-              <a:t>REST/SSE server</a:t>
-            </a:r>
-          </a:p>
-          <a:p>
-            <a:pPr lvl="1"/>
-            <a:r>
-              <a:rPr lang="hr-HR" noProof="0" dirty="0"/>
-              <a:t>T</a:t>
-            </a:r>
-            <a:r>
-              <a:rPr lang="en-US" noProof="0" dirty="0" err="1"/>
-              <a:t>hin</a:t>
-            </a:r>
-            <a:r>
-              <a:rPr lang="en-US" noProof="0" dirty="0"/>
-              <a:t> clients</a:t>
-            </a:r>
-          </a:p>
-          <a:p>
-            <a:pPr lvl="1"/>
-            <a:r>
-              <a:rPr lang="hr-HR" noProof="0" dirty="0"/>
-              <a:t>O</a:t>
-            </a:r>
-            <a:r>
-              <a:rPr lang="en-US" noProof="0" dirty="0" err="1"/>
-              <a:t>ptimized</a:t>
-            </a:r>
-            <a:r>
-              <a:rPr lang="en-US" noProof="0" dirty="0"/>
-              <a:t> for a </a:t>
-            </a:r>
-            <a:r>
-              <a:rPr lang="en-US" b="1" noProof="0" dirty="0"/>
-              <a:t>local model</a:t>
-            </a:r>
-            <a:r>
-              <a:rPr lang="en-US" noProof="0" dirty="0"/>
-              <a:t>: one GPU, slow tokens, every token paid in latency</a:t>
-            </a:r>
-          </a:p>
-          <a:p>
-            <a:pPr lvl="0"/>
-            <a:r>
-              <a:rPr lang="en-US" noProof="0" dirty="0"/>
-              <a:t>Research project · Go · SQLite · </a:t>
-            </a:r>
-            <a:r>
-              <a:rPr lang="en-US" noProof="0" dirty="0" err="1"/>
-              <a:t>goja</a:t>
-            </a:r>
-            <a:r>
-              <a:rPr lang="en-US" noProof="0" dirty="0"/>
-              <a:t> JS sandbox</a:t>
-            </a:r>
-          </a:p>
-          <a:p>
-            <a:pPr lvl="1"/>
-            <a:r>
-              <a:rPr lang="en-US" noProof="0" dirty="0"/>
-              <a:t>Lightweight, no bells-and-whistles</a:t>
-            </a:r>
-          </a:p>
-          <a:p>
-            <a:pPr lvl="1"/>
-            <a:r>
-              <a:rPr lang="en-US" noProof="0" dirty="0"/>
-              <a:t>Dubiously useful</a:t>
-            </a:r>
-          </a:p>
-        </p:txBody>
-      </p:sp>
-    </p:spTree>
-    <p:extLst>
-      <p:ext uri="{BB962C8B-B14F-4D97-AF65-F5344CB8AC3E}">
-        <p14:creationId xmlns:p14="http://schemas.microsoft.com/office/powerpoint/2010/main" val="4250528982"/>
-      </p:ext>
-    </p:extLst>
   </p:cSld>
   <p:clrMapOvr>
     <a:masterClrMapping/>

</xml_diff>